<commit_message>
feat(gsap-ui): eliminate tab disfiguring lines, fix wrapping/overlap collision, streamline NCPI banner, and activate GSAP motion architecture
</commit_message>
<xml_diff>
--- a/mandoros_dossier/MANDOROS_Global_Academic_Presentation.pptx
+++ b/mandoros_dossier/MANDOROS_Global_Academic_Presentation.pptx
@@ -21,6 +21,10 @@
     <p:sldId id="269" r:id="rId20"/>
     <p:sldId id="270" r:id="rId21"/>
     <p:sldId id="271" r:id="rId22"/>
+    <p:sldId id="272" r:id="rId23"/>
+    <p:sldId id="273" r:id="rId24"/>
+    <p:sldId id="274" r:id="rId25"/>
+    <p:sldId id="275" r:id="rId26"/>
   </p:sldIdLst>
   <p:sldSz cx="12191695" cy="6858000" type="screen4x3"/>
   <p:notesSz cx="6858000" cy="9144000"/>
@@ -7055,6 +7059,2166 @@
             <a:pPr>
               <a:defRPr sz="1000" b="1">
                 <a:solidFill>
+                  <a:srgbClr val="C084FC"/>
+                </a:solidFill>
+                <a:latin typeface="Arial"/>
+              </a:defRPr>
+            </a:pPr>
+            <a:r>
+              <a:t>RESEARCH TRANSLATION &amp; BIOSTATISTICAL RIGOR</a:t>
+            </a:r>
+          </a:p>
+        </p:txBody>
+      </p:sp>
+      <p:sp>
+        <p:nvSpPr>
+          <p:cNvPr id="3" name="TextBox 2"/>
+          <p:cNvSpPr txBox="1"/>
+          <p:nvPr/>
+        </p:nvSpPr>
+        <p:spPr>
+          <a:xfrm>
+            <a:off x="8412480" y="365760"/>
+            <a:ext cx="3017520" cy="320040"/>
+          </a:xfrm>
+          <a:prstGeom prst="rect">
+            <a:avLst/>
+          </a:prstGeom>
+          <a:noFill/>
+        </p:spPr>
+        <p:txBody>
+          <a:bodyPr wrap="none">
+            <a:spAutoFit/>
+          </a:bodyPr>
+          <a:lstStyle/>
+          <a:p>
+            <a:pPr algn="r">
+              <a:defRPr sz="1000" b="1">
+                <a:solidFill>
+                  <a:srgbClr val="94A3B8"/>
+                </a:solidFill>
+                <a:latin typeface="Arial"/>
+              </a:defRPr>
+            </a:pPr>
+            <a:r>
+              <a:t>THE 5 PILLARS OF RIGOR</a:t>
+            </a:r>
+          </a:p>
+        </p:txBody>
+      </p:sp>
+      <p:sp>
+        <p:nvSpPr>
+          <p:cNvPr id="4" name="TextBox 3"/>
+          <p:cNvSpPr txBox="1"/>
+          <p:nvPr/>
+        </p:nvSpPr>
+        <p:spPr>
+          <a:xfrm>
+            <a:off x="731520" y="685800"/>
+            <a:ext cx="10515600" cy="685800"/>
+          </a:xfrm>
+          <a:prstGeom prst="rect">
+            <a:avLst/>
+          </a:prstGeom>
+          <a:noFill/>
+        </p:spPr>
+        <p:txBody>
+          <a:bodyPr wrap="square">
+            <a:spAutoFit/>
+          </a:bodyPr>
+          <a:lstStyle/>
+          <a:p>
+            <a:pPr>
+              <a:defRPr sz="2100" b="1">
+                <a:solidFill>
+                  <a:srgbClr val="F8FAFC"/>
+                </a:solidFill>
+                <a:latin typeface="Arial"/>
+              </a:defRPr>
+            </a:pPr>
+            <a:r>
+              <a:t>The 5 Pillars of Academic Rigor &amp; Biostatistical Calibration</a:t>
+            </a:r>
+          </a:p>
+          <a:p>
+            <a:pPr>
+              <a:defRPr sz="1100">
+                <a:solidFill>
+                  <a:srgbClr val="94A3B8"/>
+                </a:solidFill>
+                <a:latin typeface="Arial"/>
+              </a:defRPr>
+            </a:pPr>
+            <a:r>
+              <a:t>End-to-End Methodology: From Cross-Study Evidence Matrix to Deterministic Power Calibration &amp; SPIRIT 2013 Protocol.</a:t>
+            </a:r>
+          </a:p>
+        </p:txBody>
+      </p:sp>
+      <p:sp>
+        <p:nvSpPr>
+          <p:cNvPr id="5" name="Rounded Rectangle 4"/>
+          <p:cNvSpPr/>
+          <p:nvPr/>
+        </p:nvSpPr>
+        <p:spPr>
+          <a:xfrm>
+            <a:off x="731520" y="1508760"/>
+            <a:ext cx="3383280" cy="4297680"/>
+          </a:xfrm>
+          <a:prstGeom prst="roundRect">
+            <a:avLst/>
+          </a:prstGeom>
+          <a:solidFill>
+            <a:srgbClr val="0F172A"/>
+          </a:solidFill>
+          <a:ln w="19050">
+            <a:solidFill>
+              <a:srgbClr val="F59E0B"/>
+            </a:solidFill>
+          </a:ln>
+        </p:spPr>
+        <p:style>
+          <a:lnRef idx="1">
+            <a:schemeClr val="accent1"/>
+          </a:lnRef>
+          <a:fillRef idx="3">
+            <a:schemeClr val="accent1"/>
+          </a:fillRef>
+          <a:effectRef idx="2">
+            <a:schemeClr val="accent1"/>
+          </a:effectRef>
+          <a:fontRef idx="minor">
+            <a:schemeClr val="lt1"/>
+          </a:fontRef>
+        </p:style>
+        <p:txBody>
+          <a:bodyPr rtlCol="0" anchor="ctr"/>
+          <a:lstStyle/>
+          <a:p>
+            <a:pPr algn="ctr"/>
+          </a:p>
+        </p:txBody>
+      </p:sp>
+      <p:sp>
+        <p:nvSpPr>
+          <p:cNvPr id="6" name="TextBox 5"/>
+          <p:cNvSpPr txBox="1"/>
+          <p:nvPr/>
+        </p:nvSpPr>
+        <p:spPr>
+          <a:xfrm>
+            <a:off x="896112" y="1673352"/>
+            <a:ext cx="3054096" cy="3968496"/>
+          </a:xfrm>
+          <a:prstGeom prst="rect">
+            <a:avLst/>
+          </a:prstGeom>
+          <a:noFill/>
+        </p:spPr>
+        <p:txBody>
+          <a:bodyPr wrap="square">
+            <a:spAutoFit/>
+          </a:bodyPr>
+          <a:lstStyle/>
+          <a:p>
+            <a:pPr>
+              <a:spcAft>
+                <a:spcPts val="400"/>
+              </a:spcAft>
+              <a:defRPr sz="950" b="1">
+                <a:solidFill>
+                  <a:srgbClr val="F59E0B"/>
+                </a:solidFill>
+                <a:latin typeface="Arial"/>
+              </a:defRPr>
+            </a:pPr>
+            <a:r>
+              <a:t>PILLARS I &amp; II: DISCOVERY &amp; REALITY GATE</a:t>
+            </a:r>
+          </a:p>
+          <a:p>
+            <a:pPr>
+              <a:spcAft>
+                <a:spcPts val="1000"/>
+              </a:spcAft>
+              <a:defRPr sz="1300" b="1">
+                <a:solidFill>
+                  <a:srgbClr val="F8FAFC"/>
+                </a:solidFill>
+                <a:latin typeface="Arial"/>
+              </a:defRPr>
+            </a:pPr>
+            <a:r>
+              <a:t>Cross-Study Evidence Matrix &amp; Reality Gate</a:t>
+            </a:r>
+          </a:p>
+          <a:p>
+            <a:pPr>
+              <a:spcAft>
+                <a:spcPts val="600"/>
+              </a:spcAft>
+              <a:defRPr sz="950">
+                <a:solidFill>
+                  <a:srgbClr val="CBD5E1"/>
+                </a:solidFill>
+                <a:latin typeface="Arial"/>
+              </a:defRPr>
+            </a:pPr>
+            <a:r>
+              <a:t>• Cross-Study Evidence Matrix (Pillar I): Dynamically aggregates PICO characteristics, comparator arms, patient demographics, and multi-endpoint data across all ingested trials.</a:t>
+            </a:r>
+          </a:p>
+          <a:p>
+            <a:pPr>
+              <a:spcAft>
+                <a:spcPts val="600"/>
+              </a:spcAft>
+              <a:defRPr sz="950">
+                <a:solidFill>
+                  <a:srgbClr val="CBD5E1"/>
+                </a:solidFill>
+                <a:latin typeface="Arial"/>
+              </a:defRPr>
+            </a:pPr>
+            <a:r>
+              <a:t>• 5 Algorithmic Gap Archetypes: Detects active comparator voids, unmeasured patient-reported outcomes (PROs), high-risk subpopulations (e.g. eGFR &lt; 30 / geriatrics), duration plateaus, and dose-titration voids.</a:t>
+            </a:r>
+          </a:p>
+          <a:p>
+            <a:pPr>
+              <a:spcAft>
+                <a:spcPts val="600"/>
+              </a:spcAft>
+              <a:defRPr sz="950">
+                <a:solidFill>
+                  <a:srgbClr val="CBD5E1"/>
+                </a:solidFill>
+                <a:latin typeface="Arial"/>
+              </a:defRPr>
+            </a:pPr>
+            <a:r>
+              <a:t>• Live Scholarly Reality Check (Pillar II): Automates real-time verification queries against ClinicalTrials.gov APIv2, PubMed, and OpenAlex to cross-reference ongoing research.</a:t>
+            </a:r>
+          </a:p>
+          <a:p>
+            <a:pPr>
+              <a:spcAft>
+                <a:spcPts val="600"/>
+              </a:spcAft>
+              <a:defRPr sz="950">
+                <a:solidFill>
+                  <a:srgbClr val="CBD5E1"/>
+                </a:solidFill>
+                <a:latin typeface="Arial"/>
+              </a:defRPr>
+            </a:pPr>
+            <a:r>
+              <a:t>• Evidence Saturation Classification: Categorizes candidate hypotheses as Open Unexplored, In-Progress, or Saturated to eliminate redundant academic waste.</a:t>
+            </a:r>
+          </a:p>
+        </p:txBody>
+      </p:sp>
+      <p:sp>
+        <p:nvSpPr>
+          <p:cNvPr id="7" name="Rounded Rectangle 6"/>
+          <p:cNvSpPr/>
+          <p:nvPr/>
+        </p:nvSpPr>
+        <p:spPr>
+          <a:xfrm>
+            <a:off x="4389120" y="1508760"/>
+            <a:ext cx="3383280" cy="4297680"/>
+          </a:xfrm>
+          <a:prstGeom prst="roundRect">
+            <a:avLst/>
+          </a:prstGeom>
+          <a:solidFill>
+            <a:srgbClr val="0F172A"/>
+          </a:solidFill>
+          <a:ln w="19050">
+            <a:solidFill>
+              <a:srgbClr val="00F5D4"/>
+            </a:solidFill>
+          </a:ln>
+        </p:spPr>
+        <p:style>
+          <a:lnRef idx="1">
+            <a:schemeClr val="accent1"/>
+          </a:lnRef>
+          <a:fillRef idx="3">
+            <a:schemeClr val="accent1"/>
+          </a:fillRef>
+          <a:effectRef idx="2">
+            <a:schemeClr val="accent1"/>
+          </a:effectRef>
+          <a:fontRef idx="minor">
+            <a:schemeClr val="lt1"/>
+          </a:fontRef>
+        </p:style>
+        <p:txBody>
+          <a:bodyPr rtlCol="0" anchor="ctr"/>
+          <a:lstStyle/>
+          <a:p>
+            <a:pPr algn="ctr"/>
+          </a:p>
+        </p:txBody>
+      </p:sp>
+      <p:sp>
+        <p:nvSpPr>
+          <p:cNvPr id="8" name="TextBox 7"/>
+          <p:cNvSpPr txBox="1"/>
+          <p:nvPr/>
+        </p:nvSpPr>
+        <p:spPr>
+          <a:xfrm>
+            <a:off x="4553712" y="1673352"/>
+            <a:ext cx="3054096" cy="3968496"/>
+          </a:xfrm>
+          <a:prstGeom prst="rect">
+            <a:avLst/>
+          </a:prstGeom>
+          <a:noFill/>
+        </p:spPr>
+        <p:txBody>
+          <a:bodyPr wrap="square">
+            <a:spAutoFit/>
+          </a:bodyPr>
+          <a:lstStyle/>
+          <a:p>
+            <a:pPr>
+              <a:spcAft>
+                <a:spcPts val="400"/>
+              </a:spcAft>
+              <a:defRPr sz="950" b="1">
+                <a:solidFill>
+                  <a:srgbClr val="00F5D4"/>
+                </a:solidFill>
+                <a:latin typeface="Arial"/>
+              </a:defRPr>
+            </a:pPr>
+            <a:r>
+              <a:t>PILLAR III: METHODOLOGICAL QUALITY</a:t>
+            </a:r>
+          </a:p>
+          <a:p>
+            <a:pPr>
+              <a:spcAft>
+                <a:spcPts val="1000"/>
+              </a:spcAft>
+              <a:defRPr sz="1300" b="1">
+                <a:solidFill>
+                  <a:srgbClr val="F8FAFC"/>
+                </a:solidFill>
+                <a:latin typeface="Arial"/>
+              </a:defRPr>
+            </a:pPr>
+            <a:r>
+              <a:t>Cochrane RoB 2.0 &amp; robvis Traffic-Light</a:t>
+            </a:r>
+          </a:p>
+          <a:p>
+            <a:pPr>
+              <a:spcAft>
+                <a:spcPts val="600"/>
+              </a:spcAft>
+              <a:defRPr sz="950">
+                <a:solidFill>
+                  <a:srgbClr val="CBD5E1"/>
+                </a:solidFill>
+                <a:latin typeface="Arial"/>
+              </a:defRPr>
+            </a:pPr>
+            <a:r>
+              <a:t>• Domain-by-Domain Bias Appraisal: Programmatically audits Cochrane RoB 2.0 domains (D1: Randomization, D2: Deviations, D3: Missing Outcomes, D4: Measurement, D5: Reporting).</a:t>
+            </a:r>
+          </a:p>
+          <a:p>
+            <a:pPr>
+              <a:spcAft>
+                <a:spcPts val="600"/>
+              </a:spcAft>
+              <a:defRPr sz="950">
+                <a:solidFill>
+                  <a:srgbClr val="CBD5E1"/>
+                </a:solidFill>
+                <a:latin typeface="Arial"/>
+              </a:defRPr>
+            </a:pPr>
+            <a:r>
+              <a:t>• Verbatim-Anchored Justifications: Binds every RoB rating to exact chunk-level text quotes extracted from the trial PDF; zero unreferenced judgments.</a:t>
+            </a:r>
+          </a:p>
+          <a:p>
+            <a:pPr>
+              <a:spcAft>
+                <a:spcPts val="600"/>
+              </a:spcAft>
+              <a:defRPr sz="950">
+                <a:solidFill>
+                  <a:srgbClr val="CBD5E1"/>
+                </a:solidFill>
+                <a:latin typeface="Arial"/>
+              </a:defRPr>
+            </a:pPr>
+            <a:r>
+              <a:t>• robvis-Grade Traffic-Light Visualization: Generates interactive Cochrane summary matrix and bar charts displaying risk distributions across the trial cohort.</a:t>
+            </a:r>
+          </a:p>
+          <a:p>
+            <a:pPr>
+              <a:spcAft>
+                <a:spcPts val="600"/>
+              </a:spcAft>
+              <a:defRPr sz="950">
+                <a:solidFill>
+                  <a:srgbClr val="CBD5E1"/>
+                </a:solidFill>
+                <a:latin typeface="Arial"/>
+              </a:defRPr>
+            </a:pPr>
+            <a:r>
+              <a:t>• CONSORT 2010 Reporting Completeness: Dissects 25-item checklist compliance including sample size prespecification, blinding mechanisms, and ITT fidelity.</a:t>
+            </a:r>
+          </a:p>
+        </p:txBody>
+      </p:sp>
+      <p:sp>
+        <p:nvSpPr>
+          <p:cNvPr id="9" name="Rounded Rectangle 8"/>
+          <p:cNvSpPr/>
+          <p:nvPr/>
+        </p:nvSpPr>
+        <p:spPr>
+          <a:xfrm>
+            <a:off x="8046720" y="1508760"/>
+            <a:ext cx="3383280" cy="4297680"/>
+          </a:xfrm>
+          <a:prstGeom prst="roundRect">
+            <a:avLst/>
+          </a:prstGeom>
+          <a:solidFill>
+            <a:srgbClr val="0F172A"/>
+          </a:solidFill>
+          <a:ln w="19050">
+            <a:solidFill>
+              <a:srgbClr val="C084FC"/>
+            </a:solidFill>
+          </a:ln>
+        </p:spPr>
+        <p:style>
+          <a:lnRef idx="1">
+            <a:schemeClr val="accent1"/>
+          </a:lnRef>
+          <a:fillRef idx="3">
+            <a:schemeClr val="accent1"/>
+          </a:fillRef>
+          <a:effectRef idx="2">
+            <a:schemeClr val="accent1"/>
+          </a:effectRef>
+          <a:fontRef idx="minor">
+            <a:schemeClr val="lt1"/>
+          </a:fontRef>
+        </p:style>
+        <p:txBody>
+          <a:bodyPr rtlCol="0" anchor="ctr"/>
+          <a:lstStyle/>
+          <a:p>
+            <a:pPr algn="ctr"/>
+          </a:p>
+        </p:txBody>
+      </p:sp>
+      <p:sp>
+        <p:nvSpPr>
+          <p:cNvPr id="10" name="TextBox 9"/>
+          <p:cNvSpPr txBox="1"/>
+          <p:nvPr/>
+        </p:nvSpPr>
+        <p:spPr>
+          <a:xfrm>
+            <a:off x="8211312" y="1673352"/>
+            <a:ext cx="3054096" cy="3968496"/>
+          </a:xfrm>
+          <a:prstGeom prst="rect">
+            <a:avLst/>
+          </a:prstGeom>
+          <a:noFill/>
+        </p:spPr>
+        <p:txBody>
+          <a:bodyPr wrap="square">
+            <a:spAutoFit/>
+          </a:bodyPr>
+          <a:lstStyle/>
+          <a:p>
+            <a:pPr>
+              <a:spcAft>
+                <a:spcPts val="400"/>
+              </a:spcAft>
+              <a:defRPr sz="950" b="1">
+                <a:solidFill>
+                  <a:srgbClr val="C084FC"/>
+                </a:solidFill>
+                <a:latin typeface="Arial"/>
+              </a:defRPr>
+            </a:pPr>
+            <a:r>
+              <a:t>PILLARS IV &amp; V: PROTOCOL &amp; POWER</a:t>
+            </a:r>
+          </a:p>
+          <a:p>
+            <a:pPr>
+              <a:spcAft>
+                <a:spcPts val="1000"/>
+              </a:spcAft>
+              <a:defRPr sz="1300" b="1">
+                <a:solidFill>
+                  <a:srgbClr val="F8FAFC"/>
+                </a:solidFill>
+                <a:latin typeface="Arial"/>
+              </a:defRPr>
+            </a:pPr>
+            <a:r>
+              <a:t>FINER Blueprint &amp; Deterministic Power</a:t>
+            </a:r>
+          </a:p>
+          <a:p>
+            <a:pPr>
+              <a:spcAft>
+                <a:spcPts val="600"/>
+              </a:spcAft>
+              <a:defRPr sz="950">
+                <a:solidFill>
+                  <a:srgbClr val="CBD5E1"/>
+                </a:solidFill>
+                <a:latin typeface="Arial"/>
+              </a:defRPr>
+            </a:pPr>
+            <a:r>
+              <a:t>• FINER Hypothesis Formulation (Pillar IV): Structures hypotheses satisfying Feasible, Interesting, Novel, Ethical, and Relevant criteria with full academic IMRAD rationale.</a:t>
+            </a:r>
+          </a:p>
+          <a:p>
+            <a:pPr>
+              <a:spcAft>
+                <a:spcPts val="600"/>
+              </a:spcAft>
+              <a:defRPr sz="950">
+                <a:solidFill>
+                  <a:srgbClr val="CBD5E1"/>
+                </a:solidFill>
+                <a:latin typeface="Arial"/>
+              </a:defRPr>
+            </a:pPr>
+            <a:r>
+              <a:t>• Deterministic Power &amp; Sample Size (Pillar V): Code-level biostatistical calculation for continuous &amp; binary endpoints; solves for N at alpha=0.05, 80% &amp; 90% power with attrition buffer.</a:t>
+            </a:r>
+          </a:p>
+          <a:p>
+            <a:pPr>
+              <a:spcAft>
+                <a:spcPts val="600"/>
+              </a:spcAft>
+              <a:defRPr sz="950">
+                <a:solidFill>
+                  <a:srgbClr val="CBD5E1"/>
+                </a:solidFill>
+                <a:latin typeface="Arial"/>
+              </a:defRPr>
+            </a:pPr>
+            <a:r>
+              <a:t>• Superiority &amp; Non-Inferiority Architecture: Supports two-sample superiority designs and non-inferiority trials with customizable margin (Delta_NI) and pooled SD (sigma).</a:t>
+            </a:r>
+          </a:p>
+          <a:p>
+            <a:pPr>
+              <a:spcAft>
+                <a:spcPts val="600"/>
+              </a:spcAft>
+              <a:defRPr sz="950">
+                <a:solidFill>
+                  <a:srgbClr val="CBD5E1"/>
+                </a:solidFill>
+                <a:latin typeface="Arial"/>
+              </a:defRPr>
+            </a:pPr>
+            <a:r>
+              <a:t>• 7-Sheet Phase 3 Research Package: Exports standardized Excel sheets (Evidence Matrix, Gaps, Reality Check, RoB, SAP, Power) plus ready-to-defend Markdown thesis dossier.</a:t>
+            </a:r>
+          </a:p>
+        </p:txBody>
+      </p:sp>
+      <p:sp>
+        <p:nvSpPr>
+          <p:cNvPr id="11" name="Rounded Rectangle 10"/>
+          <p:cNvSpPr/>
+          <p:nvPr/>
+        </p:nvSpPr>
+        <p:spPr>
+          <a:xfrm>
+            <a:off x="731520" y="5989320"/>
+            <a:ext cx="10698480" cy="438912"/>
+          </a:xfrm>
+          <a:prstGeom prst="roundRect">
+            <a:avLst/>
+          </a:prstGeom>
+          <a:solidFill>
+            <a:srgbClr val="1E293B"/>
+          </a:solidFill>
+          <a:ln w="12700">
+            <a:solidFill>
+              <a:srgbClr val="334155"/>
+            </a:solidFill>
+          </a:ln>
+        </p:spPr>
+        <p:style>
+          <a:lnRef idx="1">
+            <a:schemeClr val="accent1"/>
+          </a:lnRef>
+          <a:fillRef idx="3">
+            <a:schemeClr val="accent1"/>
+          </a:fillRef>
+          <a:effectRef idx="2">
+            <a:schemeClr val="accent1"/>
+          </a:effectRef>
+          <a:fontRef idx="minor">
+            <a:schemeClr val="lt1"/>
+          </a:fontRef>
+        </p:style>
+        <p:txBody>
+          <a:bodyPr rtlCol="0" anchor="ctr"/>
+          <a:lstStyle/>
+          <a:p>
+            <a:pPr algn="ctr"/>
+          </a:p>
+        </p:txBody>
+      </p:sp>
+      <p:sp>
+        <p:nvSpPr>
+          <p:cNvPr id="12" name="TextBox 11"/>
+          <p:cNvSpPr txBox="1"/>
+          <p:nvPr/>
+        </p:nvSpPr>
+        <p:spPr>
+          <a:xfrm>
+            <a:off x="822960" y="6016752"/>
+            <a:ext cx="10515600" cy="384048"/>
+          </a:xfrm>
+          <a:prstGeom prst="rect">
+            <a:avLst/>
+          </a:prstGeom>
+          <a:noFill/>
+        </p:spPr>
+        <p:txBody>
+          <a:bodyPr wrap="none">
+            <a:spAutoFit/>
+          </a:bodyPr>
+          <a:lstStyle/>
+          <a:p>
+            <a:pPr algn="ctr">
+              <a:defRPr sz="1000" b="1">
+                <a:solidFill>
+                  <a:srgbClr val="C084FC"/>
+                </a:solidFill>
+                <a:latin typeface="Arial"/>
+              </a:defRPr>
+            </a:pPr>
+            <a:r>
+              <a:t>5 PILLARS CERTIFIED: Evidence Matrix  |  PubMed &amp; ClinicalTrials.gov Reality Gate  |  Cochrane RoB 2.0  |  FINER Thesis  |  80/90% Power Calibration</a:t>
+            </a:r>
+          </a:p>
+        </p:txBody>
+      </p:sp>
+    </p:spTree>
+  </p:cSld>
+  <p:clrMapOvr>
+    <a:masterClrMapping/>
+  </p:clrMapOvr>
+</p:sld>
+</file>
+
+<file path=ppt/slides/slide17.xml><?xml version="1.0" encoding="utf-8"?>
+<p:sld xmlns:a="http://schemas.openxmlformats.org/drawingml/2006/main" xmlns:p="http://schemas.openxmlformats.org/presentationml/2006/main" xmlns:r="http://schemas.openxmlformats.org/officeDocument/2006/relationships">
+  <p:cSld>
+    <p:bg>
+      <p:bgPr>
+        <a:solidFill>
+          <a:srgbClr val="0B1120"/>
+        </a:solidFill>
+        <a:effectLst/>
+      </p:bgPr>
+    </p:bg>
+    <p:spTree>
+      <p:nvGrpSpPr>
+        <p:cNvPr id="1" name=""/>
+        <p:cNvGrpSpPr/>
+        <p:nvPr/>
+      </p:nvGrpSpPr>
+      <p:grpSpPr/>
+      <p:sp>
+        <p:nvSpPr>
+          <p:cNvPr id="2" name="TextBox 1"/>
+          <p:cNvSpPr txBox="1"/>
+          <p:nvPr/>
+        </p:nvSpPr>
+        <p:spPr>
+          <a:xfrm>
+            <a:off x="731520" y="365760"/>
+            <a:ext cx="7315200" cy="320040"/>
+          </a:xfrm>
+          <a:prstGeom prst="rect">
+            <a:avLst/>
+          </a:prstGeom>
+          <a:noFill/>
+        </p:spPr>
+        <p:txBody>
+          <a:bodyPr wrap="square">
+            <a:spAutoFit/>
+          </a:bodyPr>
+          <a:lstStyle/>
+          <a:p>
+            <a:pPr>
+              <a:defRPr sz="1000" b="1">
+                <a:solidFill>
+                  <a:srgbClr val="10B981"/>
+                </a:solidFill>
+                <a:latin typeface="Arial"/>
+              </a:defRPr>
+            </a:pPr>
+            <a:r>
+              <a:t>SYSTEMATIC REVIEW STANDARDS &amp; FLOW INTEGRITY</a:t>
+            </a:r>
+          </a:p>
+        </p:txBody>
+      </p:sp>
+      <p:sp>
+        <p:nvSpPr>
+          <p:cNvPr id="3" name="TextBox 2"/>
+          <p:cNvSpPr txBox="1"/>
+          <p:nvPr/>
+        </p:nvSpPr>
+        <p:spPr>
+          <a:xfrm>
+            <a:off x="8412480" y="365760"/>
+            <a:ext cx="3017520" cy="320040"/>
+          </a:xfrm>
+          <a:prstGeom prst="rect">
+            <a:avLst/>
+          </a:prstGeom>
+          <a:noFill/>
+        </p:spPr>
+        <p:txBody>
+          <a:bodyPr wrap="none">
+            <a:spAutoFit/>
+          </a:bodyPr>
+          <a:lstStyle/>
+          <a:p>
+            <a:pPr algn="r">
+              <a:defRPr sz="1000" b="1">
+                <a:solidFill>
+                  <a:srgbClr val="94A3B8"/>
+                </a:solidFill>
+                <a:latin typeface="Arial"/>
+              </a:defRPr>
+            </a:pPr>
+            <a:r>
+              <a:t>PRISMA 2020 CERTIFIED</a:t>
+            </a:r>
+          </a:p>
+        </p:txBody>
+      </p:sp>
+      <p:sp>
+        <p:nvSpPr>
+          <p:cNvPr id="4" name="TextBox 3"/>
+          <p:cNvSpPr txBox="1"/>
+          <p:nvPr/>
+        </p:nvSpPr>
+        <p:spPr>
+          <a:xfrm>
+            <a:off x="731520" y="685800"/>
+            <a:ext cx="10515600" cy="685800"/>
+          </a:xfrm>
+          <a:prstGeom prst="rect">
+            <a:avLst/>
+          </a:prstGeom>
+          <a:noFill/>
+        </p:spPr>
+        <p:txBody>
+          <a:bodyPr wrap="square">
+            <a:spAutoFit/>
+          </a:bodyPr>
+          <a:lstStyle/>
+          <a:p>
+            <a:pPr>
+              <a:defRPr sz="2100" b="1">
+                <a:solidFill>
+                  <a:srgbClr val="F8FAFC"/>
+                </a:solidFill>
+                <a:latin typeface="Arial"/>
+              </a:defRPr>
+            </a:pPr>
+            <a:r>
+              <a:t>PRISMA 2020 Intelligence &amp; Interactive Flow Architecture</a:t>
+            </a:r>
+          </a:p>
+          <a:p>
+            <a:pPr>
+              <a:defRPr sz="1100">
+                <a:solidFill>
+                  <a:srgbClr val="94A3B8"/>
+                </a:solidFill>
+                <a:latin typeface="Arial"/>
+              </a:defRPr>
+            </a:pPr>
+            <a:r>
+              <a:t>Transparent Study Selection: 4-Stage Flow Diagram, Automated Deduplication, Zero-FN Screening, and Reporting Auditing.</a:t>
+            </a:r>
+          </a:p>
+        </p:txBody>
+      </p:sp>
+      <p:sp>
+        <p:nvSpPr>
+          <p:cNvPr id="5" name="Rounded Rectangle 4"/>
+          <p:cNvSpPr/>
+          <p:nvPr/>
+        </p:nvSpPr>
+        <p:spPr>
+          <a:xfrm>
+            <a:off x="731520" y="1508760"/>
+            <a:ext cx="3383280" cy="4297680"/>
+          </a:xfrm>
+          <a:prstGeom prst="roundRect">
+            <a:avLst/>
+          </a:prstGeom>
+          <a:solidFill>
+            <a:srgbClr val="0F172A"/>
+          </a:solidFill>
+          <a:ln w="19050">
+            <a:solidFill>
+              <a:srgbClr val="10B981"/>
+            </a:solidFill>
+          </a:ln>
+        </p:spPr>
+        <p:style>
+          <a:lnRef idx="1">
+            <a:schemeClr val="accent1"/>
+          </a:lnRef>
+          <a:fillRef idx="3">
+            <a:schemeClr val="accent1"/>
+          </a:fillRef>
+          <a:effectRef idx="2">
+            <a:schemeClr val="accent1"/>
+          </a:effectRef>
+          <a:fontRef idx="minor">
+            <a:schemeClr val="lt1"/>
+          </a:fontRef>
+        </p:style>
+        <p:txBody>
+          <a:bodyPr rtlCol="0" anchor="ctr"/>
+          <a:lstStyle/>
+          <a:p>
+            <a:pPr algn="ctr"/>
+          </a:p>
+        </p:txBody>
+      </p:sp>
+      <p:sp>
+        <p:nvSpPr>
+          <p:cNvPr id="6" name="TextBox 5"/>
+          <p:cNvSpPr txBox="1"/>
+          <p:nvPr/>
+        </p:nvSpPr>
+        <p:spPr>
+          <a:xfrm>
+            <a:off x="896112" y="1673352"/>
+            <a:ext cx="3054096" cy="3968496"/>
+          </a:xfrm>
+          <a:prstGeom prst="rect">
+            <a:avLst/>
+          </a:prstGeom>
+          <a:noFill/>
+        </p:spPr>
+        <p:txBody>
+          <a:bodyPr wrap="square">
+            <a:spAutoFit/>
+          </a:bodyPr>
+          <a:lstStyle/>
+          <a:p>
+            <a:pPr>
+              <a:spcAft>
+                <a:spcPts val="400"/>
+              </a:spcAft>
+              <a:defRPr sz="950" b="1">
+                <a:solidFill>
+                  <a:srgbClr val="10B981"/>
+                </a:solidFill>
+                <a:latin typeface="Arial"/>
+              </a:defRPr>
+            </a:pPr>
+            <a:r>
+              <a:t>4-STAGE SELECTION ARCHITECTURE</a:t>
+            </a:r>
+          </a:p>
+          <a:p>
+            <a:pPr>
+              <a:spcAft>
+                <a:spcPts val="1000"/>
+              </a:spcAft>
+              <a:defRPr sz="1300" b="1">
+                <a:solidFill>
+                  <a:srgbClr val="F8FAFC"/>
+                </a:solidFill>
+                <a:latin typeface="Arial"/>
+              </a:defRPr>
+            </a:pPr>
+            <a:r>
+              <a:t>PRISMA 2020 Flow Diagram Engine</a:t>
+            </a:r>
+          </a:p>
+          <a:p>
+            <a:pPr>
+              <a:spcAft>
+                <a:spcPts val="600"/>
+              </a:spcAft>
+              <a:defRPr sz="950">
+                <a:solidFill>
+                  <a:srgbClr val="CBD5E1"/>
+                </a:solidFill>
+                <a:latin typeface="Arial"/>
+              </a:defRPr>
+            </a:pPr>
+            <a:r>
+              <a:t>• Stage 1 — Identification: Consolidates literature hits from PubMed/Medline, clinical registers (ClinicalTrials.gov), and manual PDF uploads with automated title/DOI deduplication.</a:t>
+            </a:r>
+          </a:p>
+          <a:p>
+            <a:pPr>
+              <a:spcAft>
+                <a:spcPts val="600"/>
+              </a:spcAft>
+              <a:defRPr sz="950">
+                <a:solidFill>
+                  <a:srgbClr val="CBD5E1"/>
+                </a:solidFill>
+                <a:latin typeface="Arial"/>
+              </a:defRPr>
+            </a:pPr>
+            <a:r>
+              <a:t>• Stage 2 — Screening: Systematic screening of titles and abstracts; records evaluated against pre-defined inclusion criteria with quantified exclusion logging.</a:t>
+            </a:r>
+          </a:p>
+          <a:p>
+            <a:pPr>
+              <a:spcAft>
+                <a:spcPts val="600"/>
+              </a:spcAft>
+              <a:defRPr sz="950">
+                <a:solidFill>
+                  <a:srgbClr val="CBD5E1"/>
+                </a:solidFill>
+                <a:latin typeface="Arial"/>
+              </a:defRPr>
+            </a:pPr>
+            <a:r>
+              <a:t>• Stage 3 — Eligibility: Full-text appraisal against atomic eligibility properties; every excluded record is tagged with an immutable, transparent exclusion reason.</a:t>
+            </a:r>
+          </a:p>
+          <a:p>
+            <a:pPr>
+              <a:spcAft>
+                <a:spcPts val="600"/>
+              </a:spcAft>
+              <a:defRPr sz="950">
+                <a:solidFill>
+                  <a:srgbClr val="CBD5E1"/>
+                </a:solidFill>
+                <a:latin typeface="Arial"/>
+              </a:defRPr>
+            </a:pPr>
+            <a:r>
+              <a:t>• Stage 4 — Included: Final cohort synthesis determining studies eligible for qualitative systematic review and quantitative metafor-grade pooling.</a:t>
+            </a:r>
+          </a:p>
+        </p:txBody>
+      </p:sp>
+      <p:sp>
+        <p:nvSpPr>
+          <p:cNvPr id="7" name="Rounded Rectangle 6"/>
+          <p:cNvSpPr/>
+          <p:nvPr/>
+        </p:nvSpPr>
+        <p:spPr>
+          <a:xfrm>
+            <a:off x="4389120" y="1508760"/>
+            <a:ext cx="3383280" cy="4297680"/>
+          </a:xfrm>
+          <a:prstGeom prst="roundRect">
+            <a:avLst/>
+          </a:prstGeom>
+          <a:solidFill>
+            <a:srgbClr val="0F172A"/>
+          </a:solidFill>
+          <a:ln w="19050">
+            <a:solidFill>
+              <a:srgbClr val="38BDF8"/>
+            </a:solidFill>
+          </a:ln>
+        </p:spPr>
+        <p:style>
+          <a:lnRef idx="1">
+            <a:schemeClr val="accent1"/>
+          </a:lnRef>
+          <a:fillRef idx="3">
+            <a:schemeClr val="accent1"/>
+          </a:fillRef>
+          <a:effectRef idx="2">
+            <a:schemeClr val="accent1"/>
+          </a:effectRef>
+          <a:fontRef idx="minor">
+            <a:schemeClr val="lt1"/>
+          </a:fontRef>
+        </p:style>
+        <p:txBody>
+          <a:bodyPr rtlCol="0" anchor="ctr"/>
+          <a:lstStyle/>
+          <a:p>
+            <a:pPr algn="ctr"/>
+          </a:p>
+        </p:txBody>
+      </p:sp>
+      <p:sp>
+        <p:nvSpPr>
+          <p:cNvPr id="8" name="TextBox 7"/>
+          <p:cNvSpPr txBox="1"/>
+          <p:nvPr/>
+        </p:nvSpPr>
+        <p:spPr>
+          <a:xfrm>
+            <a:off x="4553712" y="1673352"/>
+            <a:ext cx="3054096" cy="3968496"/>
+          </a:xfrm>
+          <a:prstGeom prst="rect">
+            <a:avLst/>
+          </a:prstGeom>
+          <a:noFill/>
+        </p:spPr>
+        <p:txBody>
+          <a:bodyPr wrap="square">
+            <a:spAutoFit/>
+          </a:bodyPr>
+          <a:lstStyle/>
+          <a:p>
+            <a:pPr>
+              <a:spcAft>
+                <a:spcPts val="400"/>
+              </a:spcAft>
+              <a:defRPr sz="950" b="1">
+                <a:solidFill>
+                  <a:srgbClr val="38BDF8"/>
+                </a:solidFill>
+                <a:latin typeface="Arial"/>
+              </a:defRPr>
+            </a:pPr>
+            <a:r>
+              <a:t>ZERO-FN REASONING MIDDLEWARE</a:t>
+            </a:r>
+          </a:p>
+          <a:p>
+            <a:pPr>
+              <a:spcAft>
+                <a:spcPts val="1000"/>
+              </a:spcAft>
+              <a:defRPr sz="1300" b="1">
+                <a:solidFill>
+                  <a:srgbClr val="F8FAFC"/>
+                </a:solidFill>
+                <a:latin typeface="Arial"/>
+              </a:defRPr>
+            </a:pPr>
+            <a:r>
+              <a:t>Ternary Screening &amp; Zero-FN Gate</a:t>
+            </a:r>
+          </a:p>
+          <a:p>
+            <a:pPr>
+              <a:spcAft>
+                <a:spcPts val="600"/>
+              </a:spcAft>
+              <a:defRPr sz="950">
+                <a:solidFill>
+                  <a:srgbClr val="CBD5E1"/>
+                </a:solidFill>
+                <a:latin typeface="Arial"/>
+              </a:defRPr>
+            </a:pPr>
+            <a:r>
+              <a:t>• Ternary Decision Logic (+1, -1, 0): AI assesses text chunks using strict ternary voting; indeterminate evidence (0) is never prematurely discarded.</a:t>
+            </a:r>
+          </a:p>
+          <a:p>
+            <a:pPr>
+              <a:spcAft>
+                <a:spcPts val="600"/>
+              </a:spcAft>
+              <a:defRPr sz="950">
+                <a:solidFill>
+                  <a:srgbClr val="CBD5E1"/>
+                </a:solidFill>
+                <a:latin typeface="Arial"/>
+              </a:defRPr>
+            </a:pPr>
+            <a:r>
+              <a:t>• Zero-False-Negative Safeguard: Ambiguous or borderline trials automatically pass to full-text human referee inspection, preventing accidental exclusion of key evidence.</a:t>
+            </a:r>
+          </a:p>
+          <a:p>
+            <a:pPr>
+              <a:spcAft>
+                <a:spcPts val="600"/>
+              </a:spcAft>
+              <a:defRPr sz="950">
+                <a:solidFill>
+                  <a:srgbClr val="CBD5E1"/>
+                </a:solidFill>
+                <a:latin typeface="Arial"/>
+              </a:defRPr>
+            </a:pPr>
+            <a:r>
+              <a:t>• Chunk-Level Provenance Anchoring: Every inclusion/exclusion decision is permanently anchored to document chunk IDs with verbatim justification quotes.</a:t>
+            </a:r>
+          </a:p>
+          <a:p>
+            <a:pPr>
+              <a:spcAft>
+                <a:spcPts val="600"/>
+              </a:spcAft>
+              <a:defRPr sz="950">
+                <a:solidFill>
+                  <a:srgbClr val="CBD5E1"/>
+                </a:solidFill>
+                <a:latin typeface="Arial"/>
+              </a:defRPr>
+            </a:pPr>
+            <a:r>
+              <a:t>• Multi-Reviewer Emulation: Replicates dual independent reviewer paradigms with consensus resolution for Cochrane-standard review fidelity.</a:t>
+            </a:r>
+          </a:p>
+        </p:txBody>
+      </p:sp>
+      <p:sp>
+        <p:nvSpPr>
+          <p:cNvPr id="9" name="Rounded Rectangle 8"/>
+          <p:cNvSpPr/>
+          <p:nvPr/>
+        </p:nvSpPr>
+        <p:spPr>
+          <a:xfrm>
+            <a:off x="8046720" y="1508760"/>
+            <a:ext cx="3383280" cy="4297680"/>
+          </a:xfrm>
+          <a:prstGeom prst="roundRect">
+            <a:avLst/>
+          </a:prstGeom>
+          <a:solidFill>
+            <a:srgbClr val="0F172A"/>
+          </a:solidFill>
+          <a:ln w="19050">
+            <a:solidFill>
+              <a:srgbClr val="F43F5E"/>
+            </a:solidFill>
+          </a:ln>
+        </p:spPr>
+        <p:style>
+          <a:lnRef idx="1">
+            <a:schemeClr val="accent1"/>
+          </a:lnRef>
+          <a:fillRef idx="3">
+            <a:schemeClr val="accent1"/>
+          </a:fillRef>
+          <a:effectRef idx="2">
+            <a:schemeClr val="accent1"/>
+          </a:effectRef>
+          <a:fontRef idx="minor">
+            <a:schemeClr val="lt1"/>
+          </a:fontRef>
+        </p:style>
+        <p:txBody>
+          <a:bodyPr rtlCol="0" anchor="ctr"/>
+          <a:lstStyle/>
+          <a:p>
+            <a:pPr algn="ctr"/>
+          </a:p>
+        </p:txBody>
+      </p:sp>
+      <p:sp>
+        <p:nvSpPr>
+          <p:cNvPr id="10" name="TextBox 9"/>
+          <p:cNvSpPr txBox="1"/>
+          <p:nvPr/>
+        </p:nvSpPr>
+        <p:spPr>
+          <a:xfrm>
+            <a:off x="8211312" y="1673352"/>
+            <a:ext cx="3054096" cy="3968496"/>
+          </a:xfrm>
+          <a:prstGeom prst="rect">
+            <a:avLst/>
+          </a:prstGeom>
+          <a:noFill/>
+        </p:spPr>
+        <p:txBody>
+          <a:bodyPr wrap="square">
+            <a:spAutoFit/>
+          </a:bodyPr>
+          <a:lstStyle/>
+          <a:p>
+            <a:pPr>
+              <a:spcAft>
+                <a:spcPts val="400"/>
+              </a:spcAft>
+              <a:defRPr sz="950" b="1">
+                <a:solidFill>
+                  <a:srgbClr val="F43F5E"/>
+                </a:solidFill>
+                <a:latin typeface="Arial"/>
+              </a:defRPr>
+            </a:pPr>
+            <a:r>
+              <a:t>COMPLIANCE &amp; VISUALIZATION</a:t>
+            </a:r>
+          </a:p>
+          <a:p>
+            <a:pPr>
+              <a:spcAft>
+                <a:spcPts val="1000"/>
+              </a:spcAft>
+              <a:defRPr sz="1300" b="1">
+                <a:solidFill>
+                  <a:srgbClr val="F8FAFC"/>
+                </a:solidFill>
+                <a:latin typeface="Arial"/>
+              </a:defRPr>
+            </a:pPr>
+            <a:r>
+              <a:t>PRISMA 2020 Checklist &amp; Dashboard</a:t>
+            </a:r>
+          </a:p>
+          <a:p>
+            <a:pPr>
+              <a:spcAft>
+                <a:spcPts val="600"/>
+              </a:spcAft>
+              <a:defRPr sz="950">
+                <a:solidFill>
+                  <a:srgbClr val="CBD5E1"/>
+                </a:solidFill>
+                <a:latin typeface="Arial"/>
+              </a:defRPr>
+            </a:pPr>
+            <a:r>
+              <a:t>• 27-Item PRISMA 2020 Checklist Auditor: Evaluates reporting fidelity across Title, Abstract, Introduction, Methods, Results, Discussion, and Funding.</a:t>
+            </a:r>
+          </a:p>
+          <a:p>
+            <a:pPr>
+              <a:spcAft>
+                <a:spcPts val="600"/>
+              </a:spcAft>
+              <a:defRPr sz="950">
+                <a:solidFill>
+                  <a:srgbClr val="CBD5E1"/>
+                </a:solidFill>
+                <a:latin typeface="Arial"/>
+              </a:defRPr>
+            </a:pPr>
+            <a:r>
+              <a:t>• Stand-Alone Interactive HTML Dashboard: Renders dynamic SVG/Plotly PRISMA flowcharts with clickable nodes revealing study IDs, counts, and exclusion breakdowns.</a:t>
+            </a:r>
+          </a:p>
+          <a:p>
+            <a:pPr>
+              <a:spcAft>
+                <a:spcPts val="600"/>
+              </a:spcAft>
+              <a:defRPr sz="950">
+                <a:solidFill>
+                  <a:srgbClr val="CBD5E1"/>
+                </a:solidFill>
+                <a:latin typeface="Arial"/>
+              </a:defRPr>
+            </a:pPr>
+            <a:r>
+              <a:t>• Deterministic Attrition Accounting: Enforces mathematical consistency across nodes: Identified - Duplicates = Screened; Screened - Excluded = Eligible.</a:t>
+            </a:r>
+          </a:p>
+          <a:p>
+            <a:pPr>
+              <a:spcAft>
+                <a:spcPts val="600"/>
+              </a:spcAft>
+              <a:defRPr sz="950">
+                <a:solidFill>
+                  <a:srgbClr val="CBD5E1"/>
+                </a:solidFill>
+                <a:latin typeface="Arial"/>
+              </a:defRPr>
+            </a:pPr>
+            <a:r>
+              <a:t>• Publication-Ready Vector &amp; Data Export: One-click export of PRISMA flowcharts in SVG/PNG and full audit logs in Excel for peer-reviewed journal submission.</a:t>
+            </a:r>
+          </a:p>
+        </p:txBody>
+      </p:sp>
+      <p:sp>
+        <p:nvSpPr>
+          <p:cNvPr id="11" name="Rounded Rectangle 10"/>
+          <p:cNvSpPr/>
+          <p:nvPr/>
+        </p:nvSpPr>
+        <p:spPr>
+          <a:xfrm>
+            <a:off x="731520" y="5989320"/>
+            <a:ext cx="10698480" cy="438912"/>
+          </a:xfrm>
+          <a:prstGeom prst="roundRect">
+            <a:avLst/>
+          </a:prstGeom>
+          <a:solidFill>
+            <a:srgbClr val="1E293B"/>
+          </a:solidFill>
+          <a:ln w="12700">
+            <a:solidFill>
+              <a:srgbClr val="334155"/>
+            </a:solidFill>
+          </a:ln>
+        </p:spPr>
+        <p:style>
+          <a:lnRef idx="1">
+            <a:schemeClr val="accent1"/>
+          </a:lnRef>
+          <a:fillRef idx="3">
+            <a:schemeClr val="accent1"/>
+          </a:fillRef>
+          <a:effectRef idx="2">
+            <a:schemeClr val="accent1"/>
+          </a:effectRef>
+          <a:fontRef idx="minor">
+            <a:schemeClr val="lt1"/>
+          </a:fontRef>
+        </p:style>
+        <p:txBody>
+          <a:bodyPr rtlCol="0" anchor="ctr"/>
+          <a:lstStyle/>
+          <a:p>
+            <a:pPr algn="ctr"/>
+          </a:p>
+        </p:txBody>
+      </p:sp>
+      <p:sp>
+        <p:nvSpPr>
+          <p:cNvPr id="12" name="TextBox 11"/>
+          <p:cNvSpPr txBox="1"/>
+          <p:nvPr/>
+        </p:nvSpPr>
+        <p:spPr>
+          <a:xfrm>
+            <a:off x="822960" y="6016752"/>
+            <a:ext cx="10515600" cy="384048"/>
+          </a:xfrm>
+          <a:prstGeom prst="rect">
+            <a:avLst/>
+          </a:prstGeom>
+          <a:noFill/>
+        </p:spPr>
+        <p:txBody>
+          <a:bodyPr wrap="none">
+            <a:spAutoFit/>
+          </a:bodyPr>
+          <a:lstStyle/>
+          <a:p>
+            <a:pPr algn="ctr">
+              <a:defRPr sz="1000" b="1">
+                <a:solidFill>
+                  <a:srgbClr val="10B981"/>
+                </a:solidFill>
+                <a:latin typeface="Arial"/>
+              </a:defRPr>
+            </a:pPr>
+            <a:r>
+              <a:t>PRISMA 2020 AUDIT: 4-Stage Flow Diagram  |  Ternary Zero-FN Screening  |  27-Item Checklist  |  Interactive SVG Dashboard</a:t>
+            </a:r>
+          </a:p>
+        </p:txBody>
+      </p:sp>
+    </p:spTree>
+  </p:cSld>
+  <p:clrMapOvr>
+    <a:masterClrMapping/>
+  </p:clrMapOvr>
+</p:sld>
+</file>
+
+<file path=ppt/slides/slide18.xml><?xml version="1.0" encoding="utf-8"?>
+<p:sld xmlns:a="http://schemas.openxmlformats.org/drawingml/2006/main" xmlns:p="http://schemas.openxmlformats.org/presentationml/2006/main" xmlns:r="http://schemas.openxmlformats.org/officeDocument/2006/relationships">
+  <p:cSld>
+    <p:bg>
+      <p:bgPr>
+        <a:solidFill>
+          <a:srgbClr val="0B1120"/>
+        </a:solidFill>
+        <a:effectLst/>
+      </p:bgPr>
+    </p:bg>
+    <p:spTree>
+      <p:nvGrpSpPr>
+        <p:cNvPr id="1" name=""/>
+        <p:cNvGrpSpPr/>
+        <p:nvPr/>
+      </p:nvGrpSpPr>
+      <p:grpSpPr/>
+      <p:sp>
+        <p:nvSpPr>
+          <p:cNvPr id="2" name="TextBox 1"/>
+          <p:cNvSpPr txBox="1"/>
+          <p:nvPr/>
+        </p:nvSpPr>
+        <p:spPr>
+          <a:xfrm>
+            <a:off x="731520" y="365760"/>
+            <a:ext cx="7315200" cy="320040"/>
+          </a:xfrm>
+          <a:prstGeom prst="rect">
+            <a:avLst/>
+          </a:prstGeom>
+          <a:noFill/>
+        </p:spPr>
+        <p:txBody>
+          <a:bodyPr wrap="square">
+            <a:spAutoFit/>
+          </a:bodyPr>
+          <a:lstStyle/>
+          <a:p>
+            <a:pPr>
+              <a:defRPr sz="1000" b="1">
+                <a:solidFill>
+                  <a:srgbClr val="38BDF8"/>
+                </a:solidFill>
+                <a:latin typeface="Arial"/>
+              </a:defRPr>
+            </a:pPr>
+            <a:r>
+              <a:t>CLINICAL KNOWLEDGE BASES &amp; INTEROPERABILITY</a:t>
+            </a:r>
+          </a:p>
+        </p:txBody>
+      </p:sp>
+      <p:sp>
+        <p:nvSpPr>
+          <p:cNvPr id="3" name="TextBox 2"/>
+          <p:cNvSpPr txBox="1"/>
+          <p:nvPr/>
+        </p:nvSpPr>
+        <p:spPr>
+          <a:xfrm>
+            <a:off x="8412480" y="365760"/>
+            <a:ext cx="3017520" cy="320040"/>
+          </a:xfrm>
+          <a:prstGeom prst="rect">
+            <a:avLst/>
+          </a:prstGeom>
+          <a:noFill/>
+        </p:spPr>
+        <p:txBody>
+          <a:bodyPr wrap="none">
+            <a:spAutoFit/>
+          </a:bodyPr>
+          <a:lstStyle/>
+          <a:p>
+            <a:pPr algn="r">
+              <a:defRPr sz="1000" b="1">
+                <a:solidFill>
+                  <a:srgbClr val="94A3B8"/>
+                </a:solidFill>
+                <a:latin typeface="Arial"/>
+              </a:defRPr>
+            </a:pPr>
+            <a:r>
+              <a:t>NCPI FHIR &amp; NIH APIS</a:t>
+            </a:r>
+          </a:p>
+        </p:txBody>
+      </p:sp>
+      <p:sp>
+        <p:nvSpPr>
+          <p:cNvPr id="4" name="TextBox 3"/>
+          <p:cNvSpPr txBox="1"/>
+          <p:nvPr/>
+        </p:nvSpPr>
+        <p:spPr>
+          <a:xfrm>
+            <a:off x="731520" y="685800"/>
+            <a:ext cx="10515600" cy="685800"/>
+          </a:xfrm>
+          <a:prstGeom prst="rect">
+            <a:avLst/>
+          </a:prstGeom>
+          <a:noFill/>
+        </p:spPr>
+        <p:txBody>
+          <a:bodyPr wrap="square">
+            <a:spAutoFit/>
+          </a:bodyPr>
+          <a:lstStyle/>
+          <a:p>
+            <a:pPr>
+              <a:defRPr sz="2100" b="1">
+                <a:solidFill>
+                  <a:srgbClr val="F8FAFC"/>
+                </a:solidFill>
+                <a:latin typeface="Arial"/>
+              </a:defRPr>
+            </a:pPr>
+            <a:r>
+              <a:t>External Clinical Databases, PubMed &amp; NCPI FHIR Ecosystem</a:t>
+            </a:r>
+          </a:p>
+          <a:p>
+            <a:pPr>
+              <a:defRPr sz="1100">
+                <a:solidFill>
+                  <a:srgbClr val="94A3B8"/>
+                </a:solidFill>
+                <a:latin typeface="Arial"/>
+              </a:defRPr>
+            </a:pPr>
+            <a:r>
+              <a:t>Live Bidirectional Interoperability: PubMed E-utilities, ClinicalTrials.gov APIv2, NLM RxNorm, and HL7 FHIR R4 ResearchStudy.</a:t>
+            </a:r>
+          </a:p>
+        </p:txBody>
+      </p:sp>
+      <p:sp>
+        <p:nvSpPr>
+          <p:cNvPr id="5" name="Rounded Rectangle 4"/>
+          <p:cNvSpPr/>
+          <p:nvPr/>
+        </p:nvSpPr>
+        <p:spPr>
+          <a:xfrm>
+            <a:off x="731520" y="1508760"/>
+            <a:ext cx="3383280" cy="4297680"/>
+          </a:xfrm>
+          <a:prstGeom prst="roundRect">
+            <a:avLst/>
+          </a:prstGeom>
+          <a:solidFill>
+            <a:srgbClr val="0F172A"/>
+          </a:solidFill>
+          <a:ln w="19050">
+            <a:solidFill>
+              <a:srgbClr val="38BDF8"/>
+            </a:solidFill>
+          </a:ln>
+        </p:spPr>
+        <p:style>
+          <a:lnRef idx="1">
+            <a:schemeClr val="accent1"/>
+          </a:lnRef>
+          <a:fillRef idx="3">
+            <a:schemeClr val="accent1"/>
+          </a:fillRef>
+          <a:effectRef idx="2">
+            <a:schemeClr val="accent1"/>
+          </a:effectRef>
+          <a:fontRef idx="minor">
+            <a:schemeClr val="lt1"/>
+          </a:fontRef>
+        </p:style>
+        <p:txBody>
+          <a:bodyPr rtlCol="0" anchor="ctr"/>
+          <a:lstStyle/>
+          <a:p>
+            <a:pPr algn="ctr"/>
+          </a:p>
+        </p:txBody>
+      </p:sp>
+      <p:sp>
+        <p:nvSpPr>
+          <p:cNvPr id="6" name="TextBox 5"/>
+          <p:cNvSpPr txBox="1"/>
+          <p:nvPr/>
+        </p:nvSpPr>
+        <p:spPr>
+          <a:xfrm>
+            <a:off x="896112" y="1673352"/>
+            <a:ext cx="3054096" cy="3968496"/>
+          </a:xfrm>
+          <a:prstGeom prst="rect">
+            <a:avLst/>
+          </a:prstGeom>
+          <a:noFill/>
+        </p:spPr>
+        <p:txBody>
+          <a:bodyPr wrap="square">
+            <a:spAutoFit/>
+          </a:bodyPr>
+          <a:lstStyle/>
+          <a:p>
+            <a:pPr>
+              <a:spcAft>
+                <a:spcPts val="400"/>
+              </a:spcAft>
+              <a:defRPr sz="950" b="1">
+                <a:solidFill>
+                  <a:srgbClr val="38BDF8"/>
+                </a:solidFill>
+                <a:latin typeface="Arial"/>
+              </a:defRPr>
+            </a:pPr>
+            <a:r>
+              <a:t>BIOMEDICAL LITERATURE ENGINE</a:t>
+            </a:r>
+          </a:p>
+          <a:p>
+            <a:pPr>
+              <a:spcAft>
+                <a:spcPts val="1000"/>
+              </a:spcAft>
+              <a:defRPr sz="1300" b="1">
+                <a:solidFill>
+                  <a:srgbClr val="F8FAFC"/>
+                </a:solidFill>
+                <a:latin typeface="Arial"/>
+              </a:defRPr>
+            </a:pPr>
+            <a:r>
+              <a:t>PubMed &amp; NCBI E-utilities Integration</a:t>
+            </a:r>
+          </a:p>
+          <a:p>
+            <a:pPr>
+              <a:spcAft>
+                <a:spcPts val="600"/>
+              </a:spcAft>
+              <a:defRPr sz="950">
+                <a:solidFill>
+                  <a:srgbClr val="CBD5E1"/>
+                </a:solidFill>
+                <a:latin typeface="Arial"/>
+              </a:defRPr>
+            </a:pPr>
+            <a:r>
+              <a:t>• Direct E-utilities Protocol: Interfaces NCBI Entrez API (esearch, esummary, efetch) for real-time biomedical literature verification.</a:t>
+            </a:r>
+          </a:p>
+          <a:p>
+            <a:pPr>
+              <a:spcAft>
+                <a:spcPts val="600"/>
+              </a:spcAft>
+              <a:defRPr sz="950">
+                <a:solidFill>
+                  <a:srgbClr val="CBD5E1"/>
+                </a:solidFill>
+                <a:latin typeface="Arial"/>
+              </a:defRPr>
+            </a:pPr>
+            <a:r>
+              <a:t>• PICO Deconstruction &amp; MeSH Expansion: Automatically decomposes research questions into MeSH ontology descriptors, achieving &gt;= 78% search recall.</a:t>
+            </a:r>
+          </a:p>
+          <a:p>
+            <a:pPr>
+              <a:spcAft>
+                <a:spcPts val="600"/>
+              </a:spcAft>
+              <a:defRPr sz="950">
+                <a:solidFill>
+                  <a:srgbClr val="CBD5E1"/>
+                </a:solidFill>
+                <a:latin typeface="Arial"/>
+              </a:defRPr>
+            </a:pPr>
+            <a:r>
+              <a:t>• Scholarly Gap Saturation Verification: Queries Medline to verify if discovered evidence gaps have already been addressed in recent published trials.</a:t>
+            </a:r>
+          </a:p>
+          <a:p>
+            <a:pPr>
+              <a:spcAft>
+                <a:spcPts val="600"/>
+              </a:spcAft>
+              <a:defRPr sz="950">
+                <a:solidFill>
+                  <a:srgbClr val="CBD5E1"/>
+                </a:solidFill>
+                <a:latin typeface="Arial"/>
+              </a:defRPr>
+            </a:pPr>
+            <a:r>
+              <a:t>• PubMed Central (PMC) BioC Text Mining: Extracts open-access full-text sections, tables, and XML metadata for automated citation cross-matching.</a:t>
+            </a:r>
+          </a:p>
+        </p:txBody>
+      </p:sp>
+      <p:sp>
+        <p:nvSpPr>
+          <p:cNvPr id="7" name="Rounded Rectangle 6"/>
+          <p:cNvSpPr/>
+          <p:nvPr/>
+        </p:nvSpPr>
+        <p:spPr>
+          <a:xfrm>
+            <a:off x="4389120" y="1508760"/>
+            <a:ext cx="3383280" cy="4297680"/>
+          </a:xfrm>
+          <a:prstGeom prst="roundRect">
+            <a:avLst/>
+          </a:prstGeom>
+          <a:solidFill>
+            <a:srgbClr val="0F172A"/>
+          </a:solidFill>
+          <a:ln w="19050">
+            <a:solidFill>
+              <a:srgbClr val="F59E0B"/>
+            </a:solidFill>
+          </a:ln>
+        </p:spPr>
+        <p:style>
+          <a:lnRef idx="1">
+            <a:schemeClr val="accent1"/>
+          </a:lnRef>
+          <a:fillRef idx="3">
+            <a:schemeClr val="accent1"/>
+          </a:fillRef>
+          <a:effectRef idx="2">
+            <a:schemeClr val="accent1"/>
+          </a:effectRef>
+          <a:fontRef idx="minor">
+            <a:schemeClr val="lt1"/>
+          </a:fontRef>
+        </p:style>
+        <p:txBody>
+          <a:bodyPr rtlCol="0" anchor="ctr"/>
+          <a:lstStyle/>
+          <a:p>
+            <a:pPr algn="ctr"/>
+          </a:p>
+        </p:txBody>
+      </p:sp>
+      <p:sp>
+        <p:nvSpPr>
+          <p:cNvPr id="8" name="TextBox 7"/>
+          <p:cNvSpPr txBox="1"/>
+          <p:nvPr/>
+        </p:nvSpPr>
+        <p:spPr>
+          <a:xfrm>
+            <a:off x="4553712" y="1673352"/>
+            <a:ext cx="3054096" cy="3968496"/>
+          </a:xfrm>
+          <a:prstGeom prst="rect">
+            <a:avLst/>
+          </a:prstGeom>
+          <a:noFill/>
+        </p:spPr>
+        <p:txBody>
+          <a:bodyPr wrap="square">
+            <a:spAutoFit/>
+          </a:bodyPr>
+          <a:lstStyle/>
+          <a:p>
+            <a:pPr>
+              <a:spcAft>
+                <a:spcPts val="400"/>
+              </a:spcAft>
+              <a:defRPr sz="950" b="1">
+                <a:solidFill>
+                  <a:srgbClr val="F59E0B"/>
+                </a:solidFill>
+                <a:latin typeface="Arial"/>
+              </a:defRPr>
+            </a:pPr>
+            <a:r>
+              <a:t>TRIAL REGISTRY &amp; BENCHMARKING</a:t>
+            </a:r>
+          </a:p>
+          <a:p>
+            <a:pPr>
+              <a:spcAft>
+                <a:spcPts val="1000"/>
+              </a:spcAft>
+              <a:defRPr sz="1300" b="1">
+                <a:solidFill>
+                  <a:srgbClr val="F8FAFC"/>
+                </a:solidFill>
+                <a:latin typeface="Arial"/>
+              </a:defRPr>
+            </a:pPr>
+            <a:r>
+              <a:t>Live ClinicalTrials.gov APIv2 Registry</a:t>
+            </a:r>
+          </a:p>
+          <a:p>
+            <a:pPr>
+              <a:spcAft>
+                <a:spcPts val="600"/>
+              </a:spcAft>
+              <a:defRPr sz="950">
+                <a:solidFill>
+                  <a:srgbClr val="CBD5E1"/>
+                </a:solidFill>
+                <a:latin typeface="Arial"/>
+              </a:defRPr>
+            </a:pPr>
+            <a:r>
+              <a:t>• Live Registry Synchronization: Native HTTP client directly queries ClinicalTrials.gov APIv2 REST endpoints without third-party middleware.</a:t>
+            </a:r>
+          </a:p>
+          <a:p>
+            <a:pPr>
+              <a:spcAft>
+                <a:spcPts val="600"/>
+              </a:spcAft>
+              <a:defRPr sz="950">
+                <a:solidFill>
+                  <a:srgbClr val="CBD5E1"/>
+                </a:solidFill>
+                <a:latin typeface="Arial"/>
+              </a:defRPr>
+            </a:pPr>
+            <a:r>
+              <a:t>• Automated NCT Protocol Benchmarking: Pulls official registered study protocols by NCT ID to verify pre-specified primary/secondary endpoints vs published outcomes.</a:t>
+            </a:r>
+          </a:p>
+          <a:p>
+            <a:pPr>
+              <a:spcAft>
+                <a:spcPts val="600"/>
+              </a:spcAft>
+              <a:defRPr sz="950">
+                <a:solidFill>
+                  <a:srgbClr val="CBD5E1"/>
+                </a:solidFill>
+                <a:latin typeface="Arial"/>
+              </a:defRPr>
+            </a:pPr>
+            <a:r>
+              <a:t>• Trial Recruitment &amp; Status Tracking: Audits active recruiting, completed, active-not-recruiting, and terminated trials across global sponsor portfolios.</a:t>
+            </a:r>
+          </a:p>
+          <a:p>
+            <a:pPr>
+              <a:spcAft>
+                <a:spcPts val="600"/>
+              </a:spcAft>
+              <a:defRPr sz="950">
+                <a:solidFill>
+                  <a:srgbClr val="CBD5E1"/>
+                </a:solidFill>
+                <a:latin typeface="Arial"/>
+              </a:defRPr>
+            </a:pPr>
+            <a:r>
+              <a:t>• Outcome Reporting Bias Detection: Flags discrepancies between registered trial registry endpoints and selectively reported journal publications.</a:t>
+            </a:r>
+          </a:p>
+        </p:txBody>
+      </p:sp>
+      <p:sp>
+        <p:nvSpPr>
+          <p:cNvPr id="9" name="Rounded Rectangle 8"/>
+          <p:cNvSpPr/>
+          <p:nvPr/>
+        </p:nvSpPr>
+        <p:spPr>
+          <a:xfrm>
+            <a:off x="8046720" y="1508760"/>
+            <a:ext cx="3383280" cy="4297680"/>
+          </a:xfrm>
+          <a:prstGeom prst="roundRect">
+            <a:avLst/>
+          </a:prstGeom>
+          <a:solidFill>
+            <a:srgbClr val="0F172A"/>
+          </a:solidFill>
+          <a:ln w="19050">
+            <a:solidFill>
+              <a:srgbClr val="10B981"/>
+            </a:solidFill>
+          </a:ln>
+        </p:spPr>
+        <p:style>
+          <a:lnRef idx="1">
+            <a:schemeClr val="accent1"/>
+          </a:lnRef>
+          <a:fillRef idx="3">
+            <a:schemeClr val="accent1"/>
+          </a:fillRef>
+          <a:effectRef idx="2">
+            <a:schemeClr val="accent1"/>
+          </a:effectRef>
+          <a:fontRef idx="minor">
+            <a:schemeClr val="lt1"/>
+          </a:fontRef>
+        </p:style>
+        <p:txBody>
+          <a:bodyPr rtlCol="0" anchor="ctr"/>
+          <a:lstStyle/>
+          <a:p>
+            <a:pPr algn="ctr"/>
+          </a:p>
+        </p:txBody>
+      </p:sp>
+      <p:sp>
+        <p:nvSpPr>
+          <p:cNvPr id="10" name="TextBox 9"/>
+          <p:cNvSpPr txBox="1"/>
+          <p:nvPr/>
+        </p:nvSpPr>
+        <p:spPr>
+          <a:xfrm>
+            <a:off x="8211312" y="1673352"/>
+            <a:ext cx="3054096" cy="3968496"/>
+          </a:xfrm>
+          <a:prstGeom prst="rect">
+            <a:avLst/>
+          </a:prstGeom>
+          <a:noFill/>
+        </p:spPr>
+        <p:txBody>
+          <a:bodyPr wrap="square">
+            <a:spAutoFit/>
+          </a:bodyPr>
+          <a:lstStyle/>
+          <a:p>
+            <a:pPr>
+              <a:spcAft>
+                <a:spcPts val="400"/>
+              </a:spcAft>
+              <a:defRPr sz="950" b="1">
+                <a:solidFill>
+                  <a:srgbClr val="10B981"/>
+                </a:solidFill>
+                <a:latin typeface="Arial"/>
+              </a:defRPr>
+            </a:pPr>
+            <a:r>
+              <a:t>STANDARDS &amp; INTEROPERABILITY</a:t>
+            </a:r>
+          </a:p>
+          <a:p>
+            <a:pPr>
+              <a:spcAft>
+                <a:spcPts val="1000"/>
+              </a:spcAft>
+              <a:defRPr sz="1300" b="1">
+                <a:solidFill>
+                  <a:srgbClr val="F8FAFC"/>
+                </a:solidFill>
+                <a:latin typeface="Arial"/>
+              </a:defRPr>
+            </a:pPr>
+            <a:r>
+              <a:t>NLM RxNorm &amp; HL7 FHIR Interoperability</a:t>
+            </a:r>
+          </a:p>
+          <a:p>
+            <a:pPr>
+              <a:spcAft>
+                <a:spcPts val="600"/>
+              </a:spcAft>
+              <a:defRPr sz="950">
+                <a:solidFill>
+                  <a:srgbClr val="CBD5E1"/>
+                </a:solidFill>
+                <a:latin typeface="Arial"/>
+              </a:defRPr>
+            </a:pPr>
+            <a:r>
+              <a:t>• NLM RxNorm Drug Normalization: Client-side integration with rxnav.nlm.nih.gov resolves brand names and dosage forms into canonical RxCUI codes.</a:t>
+            </a:r>
+          </a:p>
+          <a:p>
+            <a:pPr>
+              <a:spcAft>
+                <a:spcPts val="600"/>
+              </a:spcAft>
+              <a:defRPr sz="950">
+                <a:solidFill>
+                  <a:srgbClr val="CBD5E1"/>
+                </a:solidFill>
+                <a:latin typeface="Arial"/>
+              </a:defRPr>
+            </a:pPr>
+            <a:r>
+              <a:t>• Client-Side Session Caching: Caches public RxCUI mappings in sessionStorage to minimize API latency and ensure offline browser speed.</a:t>
+            </a:r>
+          </a:p>
+          <a:p>
+            <a:pPr>
+              <a:spcAft>
+                <a:spcPts val="600"/>
+              </a:spcAft>
+              <a:defRPr sz="950">
+                <a:solidFill>
+                  <a:srgbClr val="CBD5E1"/>
+                </a:solidFill>
+                <a:latin typeface="Arial"/>
+              </a:defRPr>
+            </a:pPr>
+            <a:r>
+              <a:t>• HL7 FHIR R4 ResearchStudy Mapping: Formats extracted trial evidence into standardized FHIR ResearchStudy JSON-LD clinical trial models.</a:t>
+            </a:r>
+          </a:p>
+          <a:p>
+            <a:pPr>
+              <a:spcAft>
+                <a:spcPts val="600"/>
+              </a:spcAft>
+              <a:defRPr sz="950">
+                <a:solidFill>
+                  <a:srgbClr val="CBD5E1"/>
+                </a:solidFill>
+                <a:latin typeface="Arial"/>
+              </a:defRPr>
+            </a:pPr>
+            <a:r>
+              <a:t>• NCPI FHIR Interactive Action Badges: Embedded UI badges enable one-click verification of trial identifiers, regulatory codes, and standardized vocabularies.</a:t>
+            </a:r>
+          </a:p>
+        </p:txBody>
+      </p:sp>
+      <p:sp>
+        <p:nvSpPr>
+          <p:cNvPr id="11" name="Rounded Rectangle 10"/>
+          <p:cNvSpPr/>
+          <p:nvPr/>
+        </p:nvSpPr>
+        <p:spPr>
+          <a:xfrm>
+            <a:off x="731520" y="5989320"/>
+            <a:ext cx="10698480" cy="438912"/>
+          </a:xfrm>
+          <a:prstGeom prst="roundRect">
+            <a:avLst/>
+          </a:prstGeom>
+          <a:solidFill>
+            <a:srgbClr val="1E293B"/>
+          </a:solidFill>
+          <a:ln w="12700">
+            <a:solidFill>
+              <a:srgbClr val="334155"/>
+            </a:solidFill>
+          </a:ln>
+        </p:spPr>
+        <p:style>
+          <a:lnRef idx="1">
+            <a:schemeClr val="accent1"/>
+          </a:lnRef>
+          <a:fillRef idx="3">
+            <a:schemeClr val="accent1"/>
+          </a:fillRef>
+          <a:effectRef idx="2">
+            <a:schemeClr val="accent1"/>
+          </a:effectRef>
+          <a:fontRef idx="minor">
+            <a:schemeClr val="lt1"/>
+          </a:fontRef>
+        </p:style>
+        <p:txBody>
+          <a:bodyPr rtlCol="0" anchor="ctr"/>
+          <a:lstStyle/>
+          <a:p>
+            <a:pPr algn="ctr"/>
+          </a:p>
+        </p:txBody>
+      </p:sp>
+      <p:sp>
+        <p:nvSpPr>
+          <p:cNvPr id="12" name="TextBox 11"/>
+          <p:cNvSpPr txBox="1"/>
+          <p:nvPr/>
+        </p:nvSpPr>
+        <p:spPr>
+          <a:xfrm>
+            <a:off x="822960" y="6016752"/>
+            <a:ext cx="10515600" cy="384048"/>
+          </a:xfrm>
+          <a:prstGeom prst="rect">
+            <a:avLst/>
+          </a:prstGeom>
+          <a:noFill/>
+        </p:spPr>
+        <p:txBody>
+          <a:bodyPr wrap="none">
+            <a:spAutoFit/>
+          </a:bodyPr>
+          <a:lstStyle/>
+          <a:p>
+            <a:pPr algn="ctr">
+              <a:defRPr sz="1000" b="1">
+                <a:solidFill>
+                  <a:srgbClr val="38BDF8"/>
+                </a:solidFill>
+                <a:latin typeface="Arial"/>
+              </a:defRPr>
+            </a:pPr>
+            <a:r>
+              <a:t>INTEROPERABILITY CERTIFIED: PubMed E-utilities  |  ClinicalTrials.gov APIv2  |  NLM RxNorm RxCUI  |  HL7 FHIR R4 ResearchStudy</a:t>
+            </a:r>
+          </a:p>
+        </p:txBody>
+      </p:sp>
+    </p:spTree>
+  </p:cSld>
+  <p:clrMapOvr>
+    <a:masterClrMapping/>
+  </p:clrMapOvr>
+</p:sld>
+</file>
+
+<file path=ppt/slides/slide19.xml><?xml version="1.0" encoding="utf-8"?>
+<p:sld xmlns:a="http://schemas.openxmlformats.org/drawingml/2006/main" xmlns:p="http://schemas.openxmlformats.org/presentationml/2006/main" xmlns:r="http://schemas.openxmlformats.org/officeDocument/2006/relationships">
+  <p:cSld>
+    <p:bg>
+      <p:bgPr>
+        <a:solidFill>
+          <a:srgbClr val="0B1120"/>
+        </a:solidFill>
+        <a:effectLst/>
+      </p:bgPr>
+    </p:bg>
+    <p:spTree>
+      <p:nvGrpSpPr>
+        <p:cNvPr id="1" name=""/>
+        <p:cNvGrpSpPr/>
+        <p:nvPr/>
+      </p:nvGrpSpPr>
+      <p:grpSpPr/>
+      <p:sp>
+        <p:nvSpPr>
+          <p:cNvPr id="2" name="TextBox 1"/>
+          <p:cNvSpPr txBox="1"/>
+          <p:nvPr/>
+        </p:nvSpPr>
+        <p:spPr>
+          <a:xfrm>
+            <a:off x="731520" y="365760"/>
+            <a:ext cx="7315200" cy="320040"/>
+          </a:xfrm>
+          <a:prstGeom prst="rect">
+            <a:avLst/>
+          </a:prstGeom>
+          <a:noFill/>
+        </p:spPr>
+        <p:txBody>
+          <a:bodyPr wrap="square">
+            <a:spAutoFit/>
+          </a:bodyPr>
+          <a:lstStyle/>
+          <a:p>
+            <a:pPr>
+              <a:defRPr sz="1000" b="1">
+                <a:solidFill>
                   <a:srgbClr val="38BDF8"/>
                 </a:solidFill>
                 <a:latin typeface="Arial"/>
@@ -7978,7 +10142,10 @@
           <a:lstStyle/>
           <a:p>
             <a:pPr algn="ctr">
-              <a:defRPr sz="1300" b="1">
+              <a:spcAft>
+                <a:spcPts val="800"/>
+              </a:spcAft>
+              <a:defRPr sz="1100" b="1">
                 <a:solidFill>
                   <a:srgbClr val="00F5D4"/>
                 </a:solidFill>
@@ -7986,55 +10153,87 @@
               </a:defRPr>
             </a:pPr>
             <a:r>
-              <a:t>PART I: FOUNDATIONS</a:t>
-            </a:r>
-          </a:p>
-          <a:p>
-            <a:pPr>
-              <a:spcBef>
-                <a:spcPts val="1400"/>
-              </a:spcBef>
-              <a:defRPr sz="1100">
-                <a:solidFill>
-                  <a:srgbClr val="F8FAFC"/>
-                </a:solidFill>
-                <a:latin typeface="Arial"/>
-              </a:defRPr>
-            </a:pPr>
-            <a:r>
-              <a:t>1. The Systematic Review Bottleneck</a:t>
-            </a:r>
-          </a:p>
-          <a:p>
-            <a:pPr>
-              <a:spcBef>
-                <a:spcPts val="1400"/>
-              </a:spcBef>
-              <a:defRPr sz="1100">
-                <a:solidFill>
-                  <a:srgbClr val="F8FAFC"/>
-                </a:solidFill>
-                <a:latin typeface="Arial"/>
-              </a:defRPr>
-            </a:pPr>
-            <a:r>
-              <a:t>2. System Architecture &amp; Engineering Stack</a:t>
-            </a:r>
-          </a:p>
-          <a:p>
-            <a:pPr>
-              <a:spcBef>
-                <a:spcPts val="1400"/>
-              </a:spcBef>
-              <a:defRPr sz="1100">
-                <a:solidFill>
-                  <a:srgbClr val="F8FAFC"/>
-                </a:solidFill>
-                <a:latin typeface="Arial"/>
-              </a:defRPr>
-            </a:pPr>
-            <a:r>
-              <a:t>3. The 8-Node Process Architecture (M-A-N-D-O-R-O-S)</a:t>
+              <a:t>PART I: FOUNDATIONS &amp; EXTRACTION</a:t>
+            </a:r>
+          </a:p>
+          <a:p>
+            <a:pPr>
+              <a:spcAft>
+                <a:spcPts val="400"/>
+              </a:spcAft>
+              <a:defRPr sz="950">
+                <a:solidFill>
+                  <a:srgbClr val="CBD5E1"/>
+                </a:solidFill>
+                <a:latin typeface="Arial"/>
+              </a:defRPr>
+            </a:pPr>
+            <a:r>
+              <a:t>1. The Systematic Review Bottleneck &amp; Clinical Need</a:t>
+            </a:r>
+          </a:p>
+          <a:p>
+            <a:pPr>
+              <a:spcAft>
+                <a:spcPts val="400"/>
+              </a:spcAft>
+              <a:defRPr sz="950">
+                <a:solidFill>
+                  <a:srgbClr val="CBD5E1"/>
+                </a:solidFill>
+                <a:latin typeface="Arial"/>
+              </a:defRPr>
+            </a:pPr>
+            <a:r>
+              <a:t>2. System Architecture &amp; 8-Node Pipeline (M-A-N-D-O-R-O-S)</a:t>
+            </a:r>
+          </a:p>
+          <a:p>
+            <a:pPr>
+              <a:spcAft>
+                <a:spcPts val="400"/>
+              </a:spcAft>
+              <a:defRPr sz="950">
+                <a:solidFill>
+                  <a:srgbClr val="CBD5E1"/>
+                </a:solidFill>
+                <a:latin typeface="Arial"/>
+              </a:defRPr>
+            </a:pPr>
+            <a:r>
+              <a:t>3. Stage-1 Atomic Curation (7 Sheets / 88 Fields)</a:t>
+            </a:r>
+          </a:p>
+          <a:p>
+            <a:pPr>
+              <a:spcAft>
+                <a:spcPts val="400"/>
+              </a:spcAft>
+              <a:defRPr sz="950">
+                <a:solidFill>
+                  <a:srgbClr val="CBD5E1"/>
+                </a:solidFill>
+                <a:latin typeface="Arial"/>
+              </a:defRPr>
+            </a:pPr>
+            <a:r>
+              <a:t>4. Verbatim Provenance &amp; Zero-Imputation Guarantee</a:t>
+            </a:r>
+          </a:p>
+          <a:p>
+            <a:pPr>
+              <a:spcAft>
+                <a:spcPts val="400"/>
+              </a:spcAft>
+              <a:defRPr sz="950">
+                <a:solidFill>
+                  <a:srgbClr val="CBD5E1"/>
+                </a:solidFill>
+                <a:latin typeface="Arial"/>
+              </a:defRPr>
+            </a:pPr>
+            <a:r>
+              <a:t>5. Clinical AI Governance &amp; Two-Phase 10/10 Gate</a:t>
             </a:r>
           </a:p>
         </p:txBody>
@@ -8081,7 +10280,10 @@
           <a:lstStyle/>
           <a:p>
             <a:pPr algn="ctr">
-              <a:defRPr sz="1300" b="1">
+              <a:spcAft>
+                <a:spcPts val="800"/>
+              </a:spcAft>
+              <a:defRPr sz="1100" b="1">
                 <a:solidFill>
                   <a:srgbClr val="38BDF8"/>
                 </a:solidFill>
@@ -8089,55 +10291,87 @@
               </a:defRPr>
             </a:pPr>
             <a:r>
-              <a:t>PART II: CORE ENGINES</a:t>
-            </a:r>
-          </a:p>
-          <a:p>
-            <a:pPr>
-              <a:spcBef>
-                <a:spcPts val="1400"/>
-              </a:spcBef>
-              <a:defRPr sz="1100">
-                <a:solidFill>
-                  <a:srgbClr val="F8FAFC"/>
-                </a:solidFill>
-                <a:latin typeface="Arial"/>
-              </a:defRPr>
-            </a:pPr>
-            <a:r>
-              <a:t>4. Stage-1 Atomic Curation (7 Sheets / 88 Fields)</a:t>
-            </a:r>
-          </a:p>
-          <a:p>
-            <a:pPr>
-              <a:spcBef>
-                <a:spcPts val="1400"/>
-              </a:spcBef>
-              <a:defRPr sz="1100">
-                <a:solidFill>
-                  <a:srgbClr val="F8FAFC"/>
-                </a:solidFill>
-                <a:latin typeface="Arial"/>
-              </a:defRPr>
-            </a:pPr>
-            <a:r>
-              <a:t>5. Phase-2 Multi-Trial Evidence Synthesis &amp; REML</a:t>
-            </a:r>
-          </a:p>
-          <a:p>
-            <a:pPr>
-              <a:spcBef>
-                <a:spcPts val="1400"/>
-              </a:spcBef>
-              <a:defRPr sz="1100">
-                <a:solidFill>
-                  <a:srgbClr val="F8FAFC"/>
-                </a:solidFill>
-                <a:latin typeface="Arial"/>
-              </a:defRPr>
-            </a:pPr>
-            <a:r>
-              <a:t>6. Network Meta-Analysis (NMA) &amp; SUCRA Hierarchy</a:t>
+              <a:t>PART II: SYNTHESIS &amp; METHODOLOGICAL AUDIT</a:t>
+            </a:r>
+          </a:p>
+          <a:p>
+            <a:pPr>
+              <a:spcAft>
+                <a:spcPts val="400"/>
+              </a:spcAft>
+              <a:defRPr sz="950">
+                <a:solidFill>
+                  <a:srgbClr val="CBD5E1"/>
+                </a:solidFill>
+                <a:latin typeface="Arial"/>
+              </a:defRPr>
+            </a:pPr>
+            <a:r>
+              <a:t>6. Phase-2 Multi-Trial REML &amp; 20 Supreme Rules</a:t>
+            </a:r>
+          </a:p>
+          <a:p>
+            <a:pPr>
+              <a:spcAft>
+                <a:spcPts val="400"/>
+              </a:spcAft>
+              <a:defRPr sz="950">
+                <a:solidFill>
+                  <a:srgbClr val="CBD5E1"/>
+                </a:solidFill>
+                <a:latin typeface="Arial"/>
+              </a:defRPr>
+            </a:pPr>
+            <a:r>
+              <a:t>7. Network Meta-Analysis (NMA) &amp; SUCRA Hierarchy</a:t>
+            </a:r>
+          </a:p>
+          <a:p>
+            <a:pPr>
+              <a:spcAft>
+                <a:spcPts val="400"/>
+              </a:spcAft>
+              <a:defRPr sz="950">
+                <a:solidFill>
+                  <a:srgbClr val="CBD5E1"/>
+                </a:solidFill>
+                <a:latin typeface="Arial"/>
+              </a:defRPr>
+            </a:pPr>
+            <a:r>
+              <a:t>8. TrialMind &amp; RCTMethodologyIE Validity Audit</a:t>
+            </a:r>
+          </a:p>
+          <a:p>
+            <a:pPr>
+              <a:spcAft>
+                <a:spcPts val="400"/>
+              </a:spcAft>
+              <a:defRPr sz="950">
+                <a:solidFill>
+                  <a:srgbClr val="CBD5E1"/>
+                </a:solidFill>
+                <a:latin typeface="Arial"/>
+              </a:defRPr>
+            </a:pPr>
+            <a:r>
+              <a:t>9. In-Silico Synthesis &amp; Virtual Clinical Trials</a:t>
+            </a:r>
+          </a:p>
+          <a:p>
+            <a:pPr>
+              <a:spcAft>
+                <a:spcPts val="400"/>
+              </a:spcAft>
+              <a:defRPr sz="950">
+                <a:solidFill>
+                  <a:srgbClr val="CBD5E1"/>
+                </a:solidFill>
+                <a:latin typeface="Arial"/>
+              </a:defRPr>
+            </a:pPr>
+            <a:r>
+              <a:t>10. User Walkthrough &amp; Google AI Studio BYOK</a:t>
             </a:r>
           </a:p>
         </p:txBody>
@@ -8184,63 +10418,98 @@
           <a:lstStyle/>
           <a:p>
             <a:pPr algn="ctr">
-              <a:defRPr sz="1300" b="1">
-                <a:solidFill>
-                  <a:srgbClr val="A855F7"/>
-                </a:solidFill>
-                <a:latin typeface="Arial"/>
-              </a:defRPr>
-            </a:pPr>
-            <a:r>
-              <a:t>PART III: DISCOVERY &amp; PRACTICE</a:t>
-            </a:r>
-          </a:p>
-          <a:p>
-            <a:pPr>
-              <a:spcBef>
-                <a:spcPts val="1400"/>
-              </a:spcBef>
-              <a:defRPr sz="1100">
-                <a:solidFill>
-                  <a:srgbClr val="F8FAFC"/>
-                </a:solidFill>
-                <a:latin typeface="Arial"/>
-              </a:defRPr>
-            </a:pPr>
-            <a:r>
-              <a:t>7. In-Silico Synthesis &amp; Virtual Clinical Trials</a:t>
-            </a:r>
-          </a:p>
-          <a:p>
-            <a:pPr>
-              <a:spcBef>
-                <a:spcPts val="1400"/>
-              </a:spcBef>
-              <a:defRPr sz="1100">
-                <a:solidFill>
-                  <a:srgbClr val="F8FAFC"/>
-                </a:solidFill>
-                <a:latin typeface="Arial"/>
-              </a:defRPr>
-            </a:pPr>
-            <a:r>
-              <a:t>8. Step-by-Step User Walkthrough Manual</a:t>
-            </a:r>
-          </a:p>
-          <a:p>
-            <a:pPr>
-              <a:spcBef>
-                <a:spcPts val="1400"/>
-              </a:spcBef>
-              <a:defRPr sz="1100">
-                <a:solidFill>
-                  <a:srgbClr val="F8FAFC"/>
-                </a:solidFill>
-                <a:latin typeface="Arial"/>
-              </a:defRPr>
-            </a:pPr>
-            <a:r>
-              <a:t>9. Google AI Studio BYOK Tutorial &amp; Governance</a:t>
+              <a:spcAft>
+                <a:spcPts val="800"/>
+              </a:spcAft>
+              <a:defRPr sz="1100" b="1">
+                <a:solidFill>
+                  <a:srgbClr val="C084FC"/>
+                </a:solidFill>
+                <a:latin typeface="Arial"/>
+              </a:defRPr>
+            </a:pPr>
+            <a:r>
+              <a:t>PART III: RESEARCH GAPS, PRISMA &amp; ECOSYSTEM</a:t>
+            </a:r>
+          </a:p>
+          <a:p>
+            <a:pPr>
+              <a:spcAft>
+                <a:spcPts val="400"/>
+              </a:spcAft>
+              <a:defRPr sz="950">
+                <a:solidFill>
+                  <a:srgbClr val="CBD5E1"/>
+                </a:solidFill>
+                <a:latin typeface="Arial"/>
+              </a:defRPr>
+            </a:pPr>
+            <a:r>
+              <a:t>11. Phase 3 Research Gap &amp; Thesis Navigator</a:t>
+            </a:r>
+          </a:p>
+          <a:p>
+            <a:pPr>
+              <a:spcAft>
+                <a:spcPts val="400"/>
+              </a:spcAft>
+              <a:defRPr sz="950">
+                <a:solidFill>
+                  <a:srgbClr val="CBD5E1"/>
+                </a:solidFill>
+                <a:latin typeface="Arial"/>
+              </a:defRPr>
+            </a:pPr>
+            <a:r>
+              <a:t>12. The 5 Pillars of Rigor &amp; Power Calibration</a:t>
+            </a:r>
+          </a:p>
+          <a:p>
+            <a:pPr>
+              <a:spcAft>
+                <a:spcPts val="400"/>
+              </a:spcAft>
+              <a:defRPr sz="950">
+                <a:solidFill>
+                  <a:srgbClr val="CBD5E1"/>
+                </a:solidFill>
+                <a:latin typeface="Arial"/>
+              </a:defRPr>
+            </a:pPr>
+            <a:r>
+              <a:t>13. PRISMA 2020 Intelligence &amp; 4-Stage Flow Diagram</a:t>
+            </a:r>
+          </a:p>
+          <a:p>
+            <a:pPr>
+              <a:spcAft>
+                <a:spcPts val="400"/>
+              </a:spcAft>
+              <a:defRPr sz="950">
+                <a:solidFill>
+                  <a:srgbClr val="CBD5E1"/>
+                </a:solidFill>
+                <a:latin typeface="Arial"/>
+              </a:defRPr>
+            </a:pPr>
+            <a:r>
+              <a:t>14. External Clinical Databases (PubMed, NCT, RxNorm, FHIR)</a:t>
+            </a:r>
+          </a:p>
+          <a:p>
+            <a:pPr>
+              <a:spcAft>
+                <a:spcPts val="400"/>
+              </a:spcAft>
+              <a:defRPr sz="950">
+                <a:solidFill>
+                  <a:srgbClr val="CBD5E1"/>
+                </a:solidFill>
+                <a:latin typeface="Arial"/>
+              </a:defRPr>
+            </a:pPr>
+            <a:r>
+              <a:t>15. Enterprise Cloud Security, 512MB RAM &amp; 24/7 Keep-Alive</a:t>
             </a:r>
           </a:p>
         </p:txBody>
@@ -8313,6 +10582,726 @@
             </a:pPr>
             <a:r>
               <a:t>SLIDE 02 / 12</a:t>
+            </a:r>
+          </a:p>
+        </p:txBody>
+      </p:sp>
+    </p:spTree>
+  </p:cSld>
+  <p:clrMapOvr>
+    <a:masterClrMapping/>
+  </p:clrMapOvr>
+</p:sld>
+</file>
+
+<file path=ppt/slides/slide20.xml><?xml version="1.0" encoding="utf-8"?>
+<p:sld xmlns:a="http://schemas.openxmlformats.org/drawingml/2006/main" xmlns:p="http://schemas.openxmlformats.org/presentationml/2006/main" xmlns:r="http://schemas.openxmlformats.org/officeDocument/2006/relationships">
+  <p:cSld>
+    <p:bg>
+      <p:bgPr>
+        <a:solidFill>
+          <a:srgbClr val="0B1120"/>
+        </a:solidFill>
+        <a:effectLst/>
+      </p:bgPr>
+    </p:bg>
+    <p:spTree>
+      <p:nvGrpSpPr>
+        <p:cNvPr id="1" name=""/>
+        <p:cNvGrpSpPr/>
+        <p:nvPr/>
+      </p:nvGrpSpPr>
+      <p:grpSpPr/>
+      <p:sp>
+        <p:nvSpPr>
+          <p:cNvPr id="2" name="TextBox 1"/>
+          <p:cNvSpPr txBox="1"/>
+          <p:nvPr/>
+        </p:nvSpPr>
+        <p:spPr>
+          <a:xfrm>
+            <a:off x="731520" y="365760"/>
+            <a:ext cx="7315200" cy="320040"/>
+          </a:xfrm>
+          <a:prstGeom prst="rect">
+            <a:avLst/>
+          </a:prstGeom>
+          <a:noFill/>
+        </p:spPr>
+        <p:txBody>
+          <a:bodyPr wrap="square">
+            <a:spAutoFit/>
+          </a:bodyPr>
+          <a:lstStyle/>
+          <a:p>
+            <a:pPr>
+              <a:defRPr sz="1000" b="1">
+                <a:solidFill>
+                  <a:srgbClr val="10B981"/>
+                </a:solidFill>
+                <a:latin typeface="Arial"/>
+              </a:defRPr>
+            </a:pPr>
+            <a:r>
+              <a:t>ENTERPRISE CLOUD ARCHITECTURE &amp; 24/7 RELIABILITY</a:t>
+            </a:r>
+          </a:p>
+        </p:txBody>
+      </p:sp>
+      <p:sp>
+        <p:nvSpPr>
+          <p:cNvPr id="3" name="TextBox 2"/>
+          <p:cNvSpPr txBox="1"/>
+          <p:nvPr/>
+        </p:nvSpPr>
+        <p:spPr>
+          <a:xfrm>
+            <a:off x="8412480" y="365760"/>
+            <a:ext cx="3017520" cy="320040"/>
+          </a:xfrm>
+          <a:prstGeom prst="rect">
+            <a:avLst/>
+          </a:prstGeom>
+          <a:noFill/>
+        </p:spPr>
+        <p:txBody>
+          <a:bodyPr wrap="none">
+            <a:spAutoFit/>
+          </a:bodyPr>
+          <a:lstStyle/>
+          <a:p>
+            <a:pPr algn="r">
+              <a:defRPr sz="1000" b="1">
+                <a:solidFill>
+                  <a:srgbClr val="94A3B8"/>
+                </a:solidFill>
+                <a:latin typeface="Arial"/>
+              </a:defRPr>
+            </a:pPr>
+            <a:r>
+              <a:t>PRODUCTION HARDENED</a:t>
+            </a:r>
+          </a:p>
+        </p:txBody>
+      </p:sp>
+      <p:sp>
+        <p:nvSpPr>
+          <p:cNvPr id="4" name="TextBox 3"/>
+          <p:cNvSpPr txBox="1"/>
+          <p:nvPr/>
+        </p:nvSpPr>
+        <p:spPr>
+          <a:xfrm>
+            <a:off x="731520" y="685800"/>
+            <a:ext cx="10515600" cy="685800"/>
+          </a:xfrm>
+          <a:prstGeom prst="rect">
+            <a:avLst/>
+          </a:prstGeom>
+          <a:noFill/>
+        </p:spPr>
+        <p:txBody>
+          <a:bodyPr wrap="square">
+            <a:spAutoFit/>
+          </a:bodyPr>
+          <a:lstStyle/>
+          <a:p>
+            <a:pPr>
+              <a:defRPr sz="2100" b="1">
+                <a:solidFill>
+                  <a:srgbClr val="F8FAFC"/>
+                </a:solidFill>
+                <a:latin typeface="Arial"/>
+              </a:defRPr>
+            </a:pPr>
+            <a:r>
+              <a:t>Cloud Security, Render RAM Optimization &amp; 24/7 Reliability</a:t>
+            </a:r>
+          </a:p>
+          <a:p>
+            <a:pPr>
+              <a:defRPr sz="1100">
+                <a:solidFill>
+                  <a:srgbClr val="94A3B8"/>
+                </a:solidFill>
+                <a:latin typeface="Arial"/>
+              </a:defRPr>
+            </a:pPr>
+            <a:r>
+              <a:t>Perpetual High Availability, 512MB RAM Leak-Free Operations, Path-Traversal Defense, and Zero-Latency Instant Wakeup.</a:t>
+            </a:r>
+          </a:p>
+        </p:txBody>
+      </p:sp>
+      <p:sp>
+        <p:nvSpPr>
+          <p:cNvPr id="5" name="Rounded Rectangle 4"/>
+          <p:cNvSpPr/>
+          <p:nvPr/>
+        </p:nvSpPr>
+        <p:spPr>
+          <a:xfrm>
+            <a:off x="731520" y="1508760"/>
+            <a:ext cx="3383280" cy="4297680"/>
+          </a:xfrm>
+          <a:prstGeom prst="roundRect">
+            <a:avLst/>
+          </a:prstGeom>
+          <a:solidFill>
+            <a:srgbClr val="0F172A"/>
+          </a:solidFill>
+          <a:ln w="19050">
+            <a:solidFill>
+              <a:srgbClr val="10B981"/>
+            </a:solidFill>
+          </a:ln>
+        </p:spPr>
+        <p:style>
+          <a:lnRef idx="1">
+            <a:schemeClr val="accent1"/>
+          </a:lnRef>
+          <a:fillRef idx="3">
+            <a:schemeClr val="accent1"/>
+          </a:fillRef>
+          <a:effectRef idx="2">
+            <a:schemeClr val="accent1"/>
+          </a:effectRef>
+          <a:fontRef idx="minor">
+            <a:schemeClr val="lt1"/>
+          </a:fontRef>
+        </p:style>
+        <p:txBody>
+          <a:bodyPr rtlCol="0" anchor="ctr"/>
+          <a:lstStyle/>
+          <a:p>
+            <a:pPr algn="ctr"/>
+          </a:p>
+        </p:txBody>
+      </p:sp>
+      <p:sp>
+        <p:nvSpPr>
+          <p:cNvPr id="6" name="TextBox 5"/>
+          <p:cNvSpPr txBox="1"/>
+          <p:nvPr/>
+        </p:nvSpPr>
+        <p:spPr>
+          <a:xfrm>
+            <a:off x="896112" y="1673352"/>
+            <a:ext cx="3054096" cy="3968496"/>
+          </a:xfrm>
+          <a:prstGeom prst="rect">
+            <a:avLst/>
+          </a:prstGeom>
+          <a:noFill/>
+        </p:spPr>
+        <p:txBody>
+          <a:bodyPr wrap="square">
+            <a:spAutoFit/>
+          </a:bodyPr>
+          <a:lstStyle/>
+          <a:p>
+            <a:pPr>
+              <a:spcAft>
+                <a:spcPts val="400"/>
+              </a:spcAft>
+              <a:defRPr sz="950" b="1">
+                <a:solidFill>
+                  <a:srgbClr val="10B981"/>
+                </a:solidFill>
+                <a:latin typeface="Arial"/>
+              </a:defRPr>
+            </a:pPr>
+            <a:r>
+              <a:t>ENTERPRISE SECURITY &amp; DEFENSE</a:t>
+            </a:r>
+          </a:p>
+          <a:p>
+            <a:pPr>
+              <a:spcAft>
+                <a:spcPts val="1000"/>
+              </a:spcAft>
+              <a:defRPr sz="1300" b="1">
+                <a:solidFill>
+                  <a:srgbClr val="F8FAFC"/>
+                </a:solidFill>
+                <a:latin typeface="Arial"/>
+              </a:defRPr>
+            </a:pPr>
+            <a:r>
+              <a:t>Zero-Trust Path Defense &amp; Secret Isolation</a:t>
+            </a:r>
+          </a:p>
+          <a:p>
+            <a:pPr>
+              <a:spcAft>
+                <a:spcPts val="600"/>
+              </a:spcAft>
+              <a:defRPr sz="950">
+                <a:solidFill>
+                  <a:srgbClr val="CBD5E1"/>
+                </a:solidFill>
+                <a:latin typeface="Arial"/>
+              </a:defRPr>
+            </a:pPr>
+            <a:r>
+              <a:t>• Canonical Root Path Verification: Eliminates path traversal on /api/view &amp; /api/download; strictly confines file access to resolved whitelist roots (outputs/, SESSION_ROOT, temp).</a:t>
+            </a:r>
+          </a:p>
+          <a:p>
+            <a:pPr>
+              <a:spcAft>
+                <a:spcPts val="600"/>
+              </a:spcAft>
+              <a:defRPr sz="950">
+                <a:solidFill>
+                  <a:srgbClr val="CBD5E1"/>
+                </a:solidFill>
+                <a:latin typeface="Arial"/>
+              </a:defRPr>
+            </a:pPr>
+            <a:r>
+              <a:t>• Secret Isolation in Transport Headers: Relocated sensitive Gemini API keys to secure x-goog-api-key HTTP headers, eliminating token exposure in proxy logs and referrer headers.</a:t>
+            </a:r>
+          </a:p>
+          <a:p>
+            <a:pPr>
+              <a:spcAft>
+                <a:spcPts val="600"/>
+              </a:spcAft>
+              <a:defRPr sz="950">
+                <a:solidFill>
+                  <a:srgbClr val="CBD5E1"/>
+                </a:solidFill>
+                <a:latin typeface="Arial"/>
+              </a:defRPr>
+            </a:pPr>
+            <a:r>
+              <a:t>• Contextual XSS Neutralization: Sanitizes dynamic table headers, author credits, and study titles via deterministic html.escape(), preserving interactive Plotly charts and NCPI FHIR actions.</a:t>
+            </a:r>
+          </a:p>
+          <a:p>
+            <a:pPr>
+              <a:spcAft>
+                <a:spcPts val="600"/>
+              </a:spcAft>
+              <a:defRPr sz="950">
+                <a:solidFill>
+                  <a:srgbClr val="CBD5E1"/>
+                </a:solidFill>
+                <a:latin typeface="Arial"/>
+              </a:defRPr>
+            </a:pPr>
+            <a:r>
+              <a:t>• Opt-In Access Control: Built-in basic HTTP authentication guard (MANDOROS_AUTH_*) activating strictly when environment credentials exist without breaking open clinical testing.</a:t>
+            </a:r>
+          </a:p>
+        </p:txBody>
+      </p:sp>
+      <p:sp>
+        <p:nvSpPr>
+          <p:cNvPr id="7" name="Rounded Rectangle 6"/>
+          <p:cNvSpPr/>
+          <p:nvPr/>
+        </p:nvSpPr>
+        <p:spPr>
+          <a:xfrm>
+            <a:off x="4389120" y="1508760"/>
+            <a:ext cx="3383280" cy="4297680"/>
+          </a:xfrm>
+          <a:prstGeom prst="roundRect">
+            <a:avLst/>
+          </a:prstGeom>
+          <a:solidFill>
+            <a:srgbClr val="0F172A"/>
+          </a:solidFill>
+          <a:ln w="19050">
+            <a:solidFill>
+              <a:srgbClr val="38BDF8"/>
+            </a:solidFill>
+          </a:ln>
+        </p:spPr>
+        <p:style>
+          <a:lnRef idx="1">
+            <a:schemeClr val="accent1"/>
+          </a:lnRef>
+          <a:fillRef idx="3">
+            <a:schemeClr val="accent1"/>
+          </a:fillRef>
+          <a:effectRef idx="2">
+            <a:schemeClr val="accent1"/>
+          </a:effectRef>
+          <a:fontRef idx="minor">
+            <a:schemeClr val="lt1"/>
+          </a:fontRef>
+        </p:style>
+        <p:txBody>
+          <a:bodyPr rtlCol="0" anchor="ctr"/>
+          <a:lstStyle/>
+          <a:p>
+            <a:pPr algn="ctr"/>
+          </a:p>
+        </p:txBody>
+      </p:sp>
+      <p:sp>
+        <p:nvSpPr>
+          <p:cNvPr id="8" name="TextBox 7"/>
+          <p:cNvSpPr txBox="1"/>
+          <p:nvPr/>
+        </p:nvSpPr>
+        <p:spPr>
+          <a:xfrm>
+            <a:off x="4553712" y="1673352"/>
+            <a:ext cx="3054096" cy="3968496"/>
+          </a:xfrm>
+          <a:prstGeom prst="rect">
+            <a:avLst/>
+          </a:prstGeom>
+          <a:noFill/>
+        </p:spPr>
+        <p:txBody>
+          <a:bodyPr wrap="square">
+            <a:spAutoFit/>
+          </a:bodyPr>
+          <a:lstStyle/>
+          <a:p>
+            <a:pPr>
+              <a:spcAft>
+                <a:spcPts val="400"/>
+              </a:spcAft>
+              <a:defRPr sz="950" b="1">
+                <a:solidFill>
+                  <a:srgbClr val="38BDF8"/>
+                </a:solidFill>
+                <a:latin typeface="Arial"/>
+              </a:defRPr>
+            </a:pPr>
+            <a:r>
+              <a:t>RENDER 512MB RAM OPTIMIZATION</a:t>
+            </a:r>
+          </a:p>
+          <a:p>
+            <a:pPr>
+              <a:spcAft>
+                <a:spcPts val="1000"/>
+              </a:spcAft>
+              <a:defRPr sz="1300" b="1">
+                <a:solidFill>
+                  <a:srgbClr val="F8FAFC"/>
+                </a:solidFill>
+                <a:latin typeface="Arial"/>
+              </a:defRPr>
+            </a:pPr>
+            <a:r>
+              <a:t>Deterministic Memory &amp; Leak-Free Architecture</a:t>
+            </a:r>
+          </a:p>
+          <a:p>
+            <a:pPr>
+              <a:spcAft>
+                <a:spcPts val="600"/>
+              </a:spcAft>
+              <a:defRPr sz="950">
+                <a:solidFill>
+                  <a:srgbClr val="CBD5E1"/>
+                </a:solidFill>
+                <a:latin typeface="Arial"/>
+              </a:defRPr>
+            </a:pPr>
+            <a:r>
+              <a:t>• Deterministic Workbook DOM Destruction: Every openpyxl.load_workbook is wrapped in try...finally: wb.close(), immediately freeing heavy XML/DOM memory trees upon dashboard render.</a:t>
+            </a:r>
+          </a:p>
+          <a:p>
+            <a:pPr>
+              <a:spcAft>
+                <a:spcPts val="600"/>
+              </a:spcAft>
+              <a:defRPr sz="950">
+                <a:solidFill>
+                  <a:srgbClr val="CBD5E1"/>
+                </a:solidFill>
+                <a:latin typeface="Arial"/>
+              </a:defRPr>
+            </a:pPr>
+            <a:r>
+              <a:t>• Zero File-Descriptor Leaks: PDF ingestion wrapped in guarded Python context managers (with open() as stream), ensuring streams are closed instantly after PyPDF extraction on Linux.</a:t>
+            </a:r>
+          </a:p>
+          <a:p>
+            <a:pPr>
+              <a:spcAft>
+                <a:spcPts val="600"/>
+              </a:spcAft>
+              <a:defRPr sz="950">
+                <a:solidFill>
+                  <a:srgbClr val="CBD5E1"/>
+                </a:solidFill>
+                <a:latin typeface="Arial"/>
+              </a:defRPr>
+            </a:pPr>
+            <a:r>
+              <a:t>• Resilient AI Timeout Guards: Strict 60.0s network timeout caps across OpenAI, Anthropic, and Google GenAI SDK clients prevent thread hangs, process accumulation, and worker starvation.</a:t>
+            </a:r>
+          </a:p>
+          <a:p>
+            <a:pPr>
+              <a:spcAft>
+                <a:spcPts val="600"/>
+              </a:spcAft>
+              <a:defRPr sz="950">
+                <a:solidFill>
+                  <a:srgbClr val="CBD5E1"/>
+                </a:solidFill>
+                <a:latin typeface="Arial"/>
+              </a:defRPr>
+            </a:pPr>
+            <a:r>
+              <a:t>• Lightweight Zero-Load Footprint: Operates comfortably within Render's tight 512MB free tier RAM ceiling without requiring heavyweight Celery/Redis workers or external caching daemons.</a:t>
+            </a:r>
+          </a:p>
+        </p:txBody>
+      </p:sp>
+      <p:sp>
+        <p:nvSpPr>
+          <p:cNvPr id="9" name="Rounded Rectangle 8"/>
+          <p:cNvSpPr/>
+          <p:nvPr/>
+        </p:nvSpPr>
+        <p:spPr>
+          <a:xfrm>
+            <a:off x="8046720" y="1508760"/>
+            <a:ext cx="3383280" cy="4297680"/>
+          </a:xfrm>
+          <a:prstGeom prst="roundRect">
+            <a:avLst/>
+          </a:prstGeom>
+          <a:solidFill>
+            <a:srgbClr val="0F172A"/>
+          </a:solidFill>
+          <a:ln w="19050">
+            <a:solidFill>
+              <a:srgbClr val="F59E0B"/>
+            </a:solidFill>
+          </a:ln>
+        </p:spPr>
+        <p:style>
+          <a:lnRef idx="1">
+            <a:schemeClr val="accent1"/>
+          </a:lnRef>
+          <a:fillRef idx="3">
+            <a:schemeClr val="accent1"/>
+          </a:fillRef>
+          <a:effectRef idx="2">
+            <a:schemeClr val="accent1"/>
+          </a:effectRef>
+          <a:fontRef idx="minor">
+            <a:schemeClr val="lt1"/>
+          </a:fontRef>
+        </p:style>
+        <p:txBody>
+          <a:bodyPr rtlCol="0" anchor="ctr"/>
+          <a:lstStyle/>
+          <a:p>
+            <a:pPr algn="ctr"/>
+          </a:p>
+        </p:txBody>
+      </p:sp>
+      <p:sp>
+        <p:nvSpPr>
+          <p:cNvPr id="10" name="TextBox 9"/>
+          <p:cNvSpPr txBox="1"/>
+          <p:nvPr/>
+        </p:nvSpPr>
+        <p:spPr>
+          <a:xfrm>
+            <a:off x="8211312" y="1673352"/>
+            <a:ext cx="3054096" cy="3968496"/>
+          </a:xfrm>
+          <a:prstGeom prst="rect">
+            <a:avLst/>
+          </a:prstGeom>
+          <a:noFill/>
+        </p:spPr>
+        <p:txBody>
+          <a:bodyPr wrap="square">
+            <a:spAutoFit/>
+          </a:bodyPr>
+          <a:lstStyle/>
+          <a:p>
+            <a:pPr>
+              <a:spcAft>
+                <a:spcPts val="400"/>
+              </a:spcAft>
+              <a:defRPr sz="950" b="1">
+                <a:solidFill>
+                  <a:srgbClr val="F59E0B"/>
+                </a:solidFill>
+                <a:latin typeface="Arial"/>
+              </a:defRPr>
+            </a:pPr>
+            <a:r>
+              <a:t>24/7 HIGH AVAILABILITY &amp; SPEED</a:t>
+            </a:r>
+          </a:p>
+          <a:p>
+            <a:pPr>
+              <a:spcAft>
+                <a:spcPts val="1000"/>
+              </a:spcAft>
+              <a:defRPr sz="1300" b="1">
+                <a:solidFill>
+                  <a:srgbClr val="F8FAFC"/>
+                </a:solidFill>
+                <a:latin typeface="Arial"/>
+              </a:defRPr>
+            </a:pPr>
+            <a:r>
+              <a:t>Perpetual Uptime &amp; Zero Cold-Start Latency</a:t>
+            </a:r>
+          </a:p>
+          <a:p>
+            <a:pPr>
+              <a:spcAft>
+                <a:spcPts val="600"/>
+              </a:spcAft>
+              <a:defRPr sz="950">
+                <a:solidFill>
+                  <a:srgbClr val="CBD5E1"/>
+                </a:solidFill>
+                <a:latin typeface="Arial"/>
+              </a:defRPr>
+            </a:pPr>
+            <a:r>
+              <a:t>• Automated Keep-Alive Ping Engine: Dedicated /health heartbeat endpoint probed every 5 minutes (UptimeRobot / GitHub Actions), completely neutralizing Render's 15-min idle container spin-down.</a:t>
+            </a:r>
+          </a:p>
+          <a:p>
+            <a:pPr>
+              <a:spcAft>
+                <a:spcPts val="600"/>
+              </a:spcAft>
+              <a:defRPr sz="950">
+                <a:solidFill>
+                  <a:srgbClr val="CBD5E1"/>
+                </a:solidFill>
+                <a:latin typeface="Arial"/>
+              </a:defRPr>
+            </a:pPr>
+            <a:r>
+              <a:t>• Sub-Second First-Interaction Time: Slashes initial cold-start latency from ~75 seconds down to &lt;1 second, ensuring instant, freeze-free access for clinicians and peer reviewers at all hours.</a:t>
+            </a:r>
+          </a:p>
+          <a:p>
+            <a:pPr>
+              <a:spcAft>
+                <a:spcPts val="600"/>
+              </a:spcAft>
+              <a:defRPr sz="950">
+                <a:solidFill>
+                  <a:srgbClr val="CBD5E1"/>
+                </a:solidFill>
+                <a:latin typeface="Arial"/>
+              </a:defRPr>
+            </a:pPr>
+            <a:r>
+              <a:t>• Multi-Cloud Failover Monitoring: Redundant external ping orchestrators with automated retry loops and email alerts for zero-downtime academic hosting.</a:t>
+            </a:r>
+          </a:p>
+          <a:p>
+            <a:pPr>
+              <a:spcAft>
+                <a:spcPts val="600"/>
+              </a:spcAft>
+              <a:defRPr sz="950">
+                <a:solidFill>
+                  <a:srgbClr val="CBD5E1"/>
+                </a:solidFill>
+                <a:latin typeface="Arial"/>
+              </a:defRPr>
+            </a:pPr>
+            <a:r>
+              <a:t>• Progressive Web App (PWA) Offline Cache: Caches RxNorm, NCPI FHIR, and public drug mappings locally in sessionStorage/localStorage for immediate client-side responsiveness.</a:t>
+            </a:r>
+          </a:p>
+        </p:txBody>
+      </p:sp>
+      <p:sp>
+        <p:nvSpPr>
+          <p:cNvPr id="11" name="Rounded Rectangle 10"/>
+          <p:cNvSpPr/>
+          <p:nvPr/>
+        </p:nvSpPr>
+        <p:spPr>
+          <a:xfrm>
+            <a:off x="731520" y="5989320"/>
+            <a:ext cx="10698480" cy="438912"/>
+          </a:xfrm>
+          <a:prstGeom prst="roundRect">
+            <a:avLst/>
+          </a:prstGeom>
+          <a:solidFill>
+            <a:srgbClr val="1E293B"/>
+          </a:solidFill>
+          <a:ln w="12700">
+            <a:solidFill>
+              <a:srgbClr val="334155"/>
+            </a:solidFill>
+          </a:ln>
+        </p:spPr>
+        <p:style>
+          <a:lnRef idx="1">
+            <a:schemeClr val="accent1"/>
+          </a:lnRef>
+          <a:fillRef idx="3">
+            <a:schemeClr val="accent1"/>
+          </a:fillRef>
+          <a:effectRef idx="2">
+            <a:schemeClr val="accent1"/>
+          </a:effectRef>
+          <a:fontRef idx="minor">
+            <a:schemeClr val="lt1"/>
+          </a:fontRef>
+        </p:style>
+        <p:txBody>
+          <a:bodyPr rtlCol="0" anchor="ctr"/>
+          <a:lstStyle/>
+          <a:p>
+            <a:pPr algn="ctr"/>
+          </a:p>
+        </p:txBody>
+      </p:sp>
+      <p:sp>
+        <p:nvSpPr>
+          <p:cNvPr id="12" name="TextBox 11"/>
+          <p:cNvSpPr txBox="1"/>
+          <p:nvPr/>
+        </p:nvSpPr>
+        <p:spPr>
+          <a:xfrm>
+            <a:off x="822960" y="6016752"/>
+            <a:ext cx="10515600" cy="384048"/>
+          </a:xfrm>
+          <a:prstGeom prst="rect">
+            <a:avLst/>
+          </a:prstGeom>
+          <a:noFill/>
+        </p:spPr>
+        <p:txBody>
+          <a:bodyPr wrap="none">
+            <a:spAutoFit/>
+          </a:bodyPr>
+          <a:lstStyle/>
+          <a:p>
+            <a:pPr algn="ctr">
+              <a:defRPr sz="1000" b="1">
+                <a:solidFill>
+                  <a:srgbClr val="10B981"/>
+                </a:solidFill>
+                <a:latin typeface="Arial"/>
+              </a:defRPr>
+            </a:pPr>
+            <a:r>
+              <a:t>PRODUCTION HARDENED: 24/7 Keep-Alive  |  512MB RAM Leak-Free  |  Canonical Path Defense  |  Header Token Isolation  |  &lt;1s Instant Wakeup</a:t>
             </a:r>
           </a:p>
         </p:txBody>

</xml_diff>